<commit_message>
Add presentation slides — 10 slides covering Part A and Part B
</commit_message>
<xml_diff>
--- a/DDoS_Analytics_Presentation.pptx
+++ b/DDoS_Analytics_Presentation.pptx
@@ -4,6 +4,9 @@
   <p:sldMasterIdLst>
     <p:sldMasterId id="2147483648" r:id="rId1"/>
   </p:sldMasterIdLst>
+  <p:notesMasterIdLst>
+    <p:notesMasterId r:id="rId12"/>
+  </p:notesMasterIdLst>
   <p:sldIdLst>
     <p:sldId id="256" r:id="rId2"/>
     <p:sldId id="257" r:id="rId3"/>
@@ -16,10 +19,7 @@
     <p:sldId id="264" r:id="rId10"/>
     <p:sldId id="265" r:id="rId11"/>
   </p:sldIdLst>
-  <p:notesMasterIdLst>
-    <p:notesMasterId r:id="rId12"/>
-  </p:notesMasterIdLst>
-  <p:sldSz cx="9144000" cy="5143500"/>
+  <p:sldSz cx="9144000" cy="5143500" type="screen16x9"/>
   <p:notesSz cx="5143500" cy="9144000"/>
   <p:defaultTextStyle>
     <a:lvl1pPr marL="0" algn="l" defTabSz="914400" rtl="0" eaLnBrk="1" latinLnBrk="0" hangingPunct="1">
@@ -113,6 +113,11 @@
       </a:defRPr>
     </a:lvl9pPr>
   </p:defaultTextStyle>
+  <p:extLst>
+    <p:ext uri="{EFAFB233-063F-42B5-8137-9DF3F51BA10A}">
+      <p15:sldGuideLst xmlns:p15="http://schemas.microsoft.com/office/powerpoint/2012/main"/>
+    </p:ext>
+  </p:extLst>
 </p:presentation>
 </file>
 
@@ -138,234 +143,10 @@
           <a:chExt cx="0" cy="0"/>
         </a:xfrm>
       </p:grpSpPr>
-      <p:sp>
-        <p:nvSpPr>
-          <p:cNvPr id="2" name="Header Placeholder 1"/>
-          <p:cNvSpPr>
-            <a:spLocks noGrp="1"/>
-          </p:cNvSpPr>
-          <p:nvPr>
-            <p:ph type="hdr" sz="quarter"/>
-          </p:nvPr>
-        </p:nvSpPr>
-        <p:spPr>
-          <a:xfrm>
-            <a:off x="0" y="0"/>
-            <a:ext cx="2971800" cy="458788"/>
-          </a:xfrm>
-          <a:prstGeom prst="rect">
-            <a:avLst/>
-          </a:prstGeom>
-        </p:spPr>
-        <p:txBody>
-          <a:bodyPr vert="horz" lIns="91440" tIns="45720" rIns="91440" bIns="45720" rtlCol="0"/>
-          <a:lstStyle>
-            <a:lvl1pPr algn="l">
-              <a:defRPr sz="1200"/>
-            </a:lvl1pPr>
-          </a:lstStyle>
-          <a:p>
-            <a:endParaRPr lang="en-US"/>
-          </a:p>
-        </p:txBody>
-      </p:sp>
-      <p:sp>
-        <p:nvSpPr>
-          <p:cNvPr id="3" name="Date Placeholder 2"/>
-          <p:cNvSpPr>
-            <a:spLocks noGrp="1"/>
-          </p:cNvSpPr>
-          <p:nvPr>
-            <p:ph type="dt" idx="1"/>
-          </p:nvPr>
-        </p:nvSpPr>
-        <p:spPr>
-          <a:xfrm>
-            <a:off x="3884613" y="0"/>
-            <a:ext cx="2971800" cy="458788"/>
-          </a:xfrm>
-          <a:prstGeom prst="rect">
-            <a:avLst/>
-          </a:prstGeom>
-        </p:spPr>
-        <p:txBody>
-          <a:bodyPr vert="horz" lIns="91440" tIns="45720" rIns="91440" bIns="45720" rtlCol="0"/>
-          <a:lstStyle>
-            <a:lvl1pPr algn="r">
-              <a:defRPr sz="1200"/>
-            </a:lvl1pPr>
-          </a:lstStyle>
-          <a:p>
-            <a:fld id="{5282F153-3F37-0F45-9E97-73ACFA13230C}" type="datetimeFigureOut">
-              <a:rPr lang="en-US"/>
-              <a:t>7/23/19</a:t>
-            </a:fld>
-            <a:endParaRPr lang="en-US"/>
-          </a:p>
-        </p:txBody>
-      </p:sp>
-      <p:sp>
-        <p:nvSpPr>
-          <p:cNvPr id="4" name="Slide Image Placeholder 3"/>
-          <p:cNvSpPr>
-            <a:spLocks noGrp="1" noRot="1" noChangeAspect="1"/>
-          </p:cNvSpPr>
-          <p:nvPr>
-            <p:ph type="sldImg" idx="2"/>
-          </p:nvPr>
-        </p:nvSpPr>
-        <p:spPr>
-          <a:xfrm>
-            <a:off x="685800" y="1143000"/>
-            <a:ext cx="5486400" cy="3086100"/>
-          </a:xfrm>
-          <a:prstGeom prst="rect">
-            <a:avLst/>
-          </a:prstGeom>
-          <a:noFill/>
-          <a:ln w="12700">
-            <a:solidFill>
-              <a:prstClr val="black"/>
-            </a:solidFill>
-          </a:ln>
-        </p:spPr>
-        <p:txBody>
-          <a:bodyPr vert="horz" lIns="91440" tIns="45720" rIns="91440" bIns="45720" rtlCol="0" anchor="ctr"/>
-          <a:lstStyle/>
-          <a:p>
-            <a:endParaRPr lang="en-US"/>
-          </a:p>
-        </p:txBody>
-      </p:sp>
-      <p:sp>
-        <p:nvSpPr>
-          <p:cNvPr id="5" name="Notes Placeholder 4"/>
-          <p:cNvSpPr>
-            <a:spLocks noGrp="1"/>
-          </p:cNvSpPr>
-          <p:nvPr>
-            <p:ph type="body" sz="quarter" idx="3"/>
-          </p:nvPr>
-        </p:nvSpPr>
-        <p:spPr>
-          <a:xfrm>
-            <a:off x="685800" y="4400550"/>
-            <a:ext cx="5486400" cy="3600450"/>
-          </a:xfrm>
-          <a:prstGeom prst="rect">
-            <a:avLst/>
-          </a:prstGeom>
-        </p:spPr>
-        <p:txBody>
-          <a:bodyPr vert="horz" lIns="91440" tIns="45720" rIns="91440" bIns="45720" rtlCol="0"/>
-          <a:lstStyle/>
-          <a:p>
-            <a:pPr lvl="0"/>
-            <a:r>
-              <a:rPr lang="en-US"/>
-              <a:t>Click to edit Master text styles</a:t>
-            </a:r>
-          </a:p>
-          <a:p>
-            <a:pPr lvl="1"/>
-            <a:r>
-              <a:rPr lang="en-US"/>
-              <a:t>Second level</a:t>
-            </a:r>
-          </a:p>
-          <a:p>
-            <a:pPr lvl="2"/>
-            <a:r>
-              <a:rPr lang="en-US"/>
-              <a:t>Third level</a:t>
-            </a:r>
-          </a:p>
-          <a:p>
-            <a:pPr lvl="3"/>
-            <a:r>
-              <a:rPr lang="en-US"/>
-              <a:t>Fourth level</a:t>
-            </a:r>
-          </a:p>
-          <a:p>
-            <a:pPr lvl="4"/>
-            <a:r>
-              <a:rPr lang="en-US"/>
-              <a:t>Fifth level</a:t>
-            </a:r>
-          </a:p>
-        </p:txBody>
-      </p:sp>
-      <p:sp>
-        <p:nvSpPr>
-          <p:cNvPr id="6" name="Footer Placeholder 5"/>
-          <p:cNvSpPr>
-            <a:spLocks noGrp="1"/>
-          </p:cNvSpPr>
-          <p:nvPr>
-            <p:ph type="ftr" sz="quarter" idx="4"/>
-          </p:nvPr>
-        </p:nvSpPr>
-        <p:spPr>
-          <a:xfrm>
-            <a:off x="0" y="8685213"/>
-            <a:ext cx="2971800" cy="458787"/>
-          </a:xfrm>
-          <a:prstGeom prst="rect">
-            <a:avLst/>
-          </a:prstGeom>
-        </p:spPr>
-        <p:txBody>
-          <a:bodyPr vert="horz" lIns="91440" tIns="45720" rIns="91440" bIns="45720" rtlCol="0" anchor="b"/>
-          <a:lstStyle>
-            <a:lvl1pPr algn="l">
-              <a:defRPr sz="1200"/>
-            </a:lvl1pPr>
-          </a:lstStyle>
-          <a:p>
-            <a:endParaRPr lang="en-US"/>
-          </a:p>
-        </p:txBody>
-      </p:sp>
-      <p:sp>
-        <p:nvSpPr>
-          <p:cNvPr id="7" name="Slide Number Placeholder 6"/>
-          <p:cNvSpPr>
-            <a:spLocks noGrp="1"/>
-          </p:cNvSpPr>
-          <p:nvPr>
-            <p:ph type="sldNum" sz="quarter" idx="5"/>
-          </p:nvPr>
-        </p:nvSpPr>
-        <p:spPr>
-          <a:xfrm>
-            <a:off x="3884613" y="8685213"/>
-            <a:ext cx="2971800" cy="458787"/>
-          </a:xfrm>
-          <a:prstGeom prst="rect">
-            <a:avLst/>
-          </a:prstGeom>
-        </p:spPr>
-        <p:txBody>
-          <a:bodyPr vert="horz" lIns="91440" tIns="45720" rIns="91440" bIns="45720" rtlCol="0" anchor="b"/>
-          <a:lstStyle>
-            <a:lvl1pPr algn="r">
-              <a:defRPr sz="1200"/>
-            </a:lvl1pPr>
-          </a:lstStyle>
-          <a:p>
-            <a:fld id="{CE5E9CC1-C706-0F49-92D6-E571CC5EEA8F}" type="slidenum">
-              <a:rPr lang="en-US"/>
-              <a:t>‹#›</a:t>
-            </a:fld>
-            <a:endParaRPr lang="en-US"/>
-          </a:p>
-        </p:txBody>
-      </p:sp>
     </p:spTree>
     <p:extLst>
       <p:ext uri="{BB962C8B-B14F-4D97-AF65-F5344CB8AC3E}">
-        <p14:creationId xmlns:p14="http://schemas.microsoft.com/office/powerpoint/2010/main" val="1024086991"/>
+        <p14:creationId xmlns:p14="http://schemas.microsoft.com/office/powerpoint/2010/main" val="2212907020"/>
       </p:ext>
     </p:extLst>
   </p:cSld>
@@ -509,10 +290,6 @@
           <a:bodyPr/>
           <a:lstStyle/>
           <a:p>
-            <a:r>
-              <a:rPr lang="en-US" dirty="0"/>
-              <a:t/>
-            </a:r>
             <a:endParaRPr lang="en-US" dirty="0"/>
           </a:p>
         </p:txBody>
@@ -597,10 +374,6 @@
           <a:bodyPr/>
           <a:lstStyle/>
           <a:p>
-            <a:r>
-              <a:rPr lang="en-US" dirty="0"/>
-              <a:t/>
-            </a:r>
             <a:endParaRPr lang="en-US" dirty="0"/>
           </a:p>
         </p:txBody>
@@ -685,10 +458,6 @@
           <a:bodyPr/>
           <a:lstStyle/>
           <a:p>
-            <a:r>
-              <a:rPr lang="en-US" dirty="0"/>
-              <a:t/>
-            </a:r>
             <a:endParaRPr lang="en-US" dirty="0"/>
           </a:p>
         </p:txBody>
@@ -773,10 +542,6 @@
           <a:bodyPr/>
           <a:lstStyle/>
           <a:p>
-            <a:r>
-              <a:rPr lang="en-US" dirty="0"/>
-              <a:t/>
-            </a:r>
             <a:endParaRPr lang="en-US" dirty="0"/>
           </a:p>
         </p:txBody>
@@ -861,10 +626,6 @@
           <a:bodyPr/>
           <a:lstStyle/>
           <a:p>
-            <a:r>
-              <a:rPr lang="en-US" dirty="0"/>
-              <a:t/>
-            </a:r>
             <a:endParaRPr lang="en-US" dirty="0"/>
           </a:p>
         </p:txBody>
@@ -949,10 +710,6 @@
           <a:bodyPr/>
           <a:lstStyle/>
           <a:p>
-            <a:r>
-              <a:rPr lang="en-US" dirty="0"/>
-              <a:t/>
-            </a:r>
             <a:endParaRPr lang="en-US" dirty="0"/>
           </a:p>
         </p:txBody>
@@ -1037,10 +794,6 @@
           <a:bodyPr/>
           <a:lstStyle/>
           <a:p>
-            <a:r>
-              <a:rPr lang="en-US" dirty="0"/>
-              <a:t/>
-            </a:r>
             <a:endParaRPr lang="en-US" dirty="0"/>
           </a:p>
         </p:txBody>
@@ -1125,10 +878,6 @@
           <a:bodyPr/>
           <a:lstStyle/>
           <a:p>
-            <a:r>
-              <a:rPr lang="en-US" dirty="0"/>
-              <a:t/>
-            </a:r>
             <a:endParaRPr lang="en-US" dirty="0"/>
           </a:p>
         </p:txBody>
@@ -1213,10 +962,6 @@
           <a:bodyPr/>
           <a:lstStyle/>
           <a:p>
-            <a:r>
-              <a:rPr lang="en-US" dirty="0"/>
-              <a:t/>
-            </a:r>
             <a:endParaRPr lang="en-US" dirty="0"/>
           </a:p>
         </p:txBody>
@@ -1301,10 +1046,6 @@
           <a:bodyPr/>
           <a:lstStyle/>
           <a:p>
-            <a:r>
-              <a:rPr lang="en-US" dirty="0"/>
-              <a:t/>
-            </a:r>
             <a:endParaRPr lang="en-US" dirty="0"/>
           </a:p>
         </p:txBody>
@@ -1378,6 +1119,11 @@
 <file path=ppt/slideMasters/slideMaster1.xml><?xml version="1.0" encoding="utf-8"?>
 <p:sldMaster xmlns:a="http://schemas.openxmlformats.org/drawingml/2006/main" xmlns:r="http://schemas.openxmlformats.org/officeDocument/2006/relationships" xmlns:p="http://schemas.openxmlformats.org/presentationml/2006/main">
   <p:cSld>
+    <p:bg>
+      <p:bgRef idx="1001">
+        <a:schemeClr val="bg1"/>
+      </p:bgRef>
+    </p:bg>
     <p:spTree>
       <p:nvGrpSpPr>
         <p:cNvPr id="1" name=""/>
@@ -1660,6 +1406,7 @@
         <a:solidFill>
           <a:srgbClr val="1A1A2E"/>
         </a:solidFill>
+        <a:effectLst/>
       </p:bgPr>
     </p:bg>
     <p:spTree>
@@ -1700,6 +1447,13 @@
             <a:prstDash val="solid"/>
           </a:ln>
         </p:spPr>
+        <p:txBody>
+          <a:bodyPr/>
+          <a:lstStyle/>
+          <a:p>
+            <a:endParaRPr lang="en-US"/>
+          </a:p>
+        </p:txBody>
       </p:sp>
       <p:sp>
         <p:nvSpPr>
@@ -1722,7 +1476,7 @@
           <a:bodyPr wrap="square" lIns="0" tIns="0" rIns="0" bIns="0" rtlCol="0" anchor="ctr"/>
           <a:lstStyle/>
           <a:p>
-            <a:pPr indent="0" marL="0">
+            <a:pPr marL="0" indent="0">
               <a:buNone/>
             </a:pPr>
             <a:r>
@@ -1758,7 +1512,7 @@
           <a:bodyPr wrap="square" lIns="0" tIns="0" rIns="0" bIns="0" rtlCol="0" anchor="ctr"/>
           <a:lstStyle/>
           <a:p>
-            <a:pPr indent="0" marL="0">
+            <a:pPr marL="0" indent="0">
               <a:buNone/>
             </a:pPr>
             <a:r>
@@ -1795,6 +1549,13 @@
             <a:prstDash val="solid"/>
           </a:ln>
         </p:spPr>
+        <p:txBody>
+          <a:bodyPr/>
+          <a:lstStyle/>
+          <a:p>
+            <a:endParaRPr lang="en-US"/>
+          </a:p>
+        </p:txBody>
       </p:sp>
       <p:sp>
         <p:nvSpPr>
@@ -1817,7 +1578,7 @@
           <a:bodyPr wrap="square" lIns="0" tIns="0" rIns="0" bIns="0" rtlCol="0" anchor="ctr"/>
           <a:lstStyle/>
           <a:p>
-            <a:pPr indent="0" marL="0">
+            <a:pPr marL="0" indent="0">
               <a:lnSpc>
                 <a:spcPct val="140000"/>
               </a:lnSpc>
@@ -1834,7 +1595,7 @@
             <a:endParaRPr lang="en-US" sz="1300" dirty="0"/>
           </a:p>
           <a:p>
-            <a:pPr indent="0" marL="0">
+            <a:pPr marL="0" indent="0">
               <a:lnSpc>
                 <a:spcPct val="140000"/>
               </a:lnSpc>
@@ -1851,7 +1612,7 @@
             <a:endParaRPr lang="en-US" sz="1300" dirty="0"/>
           </a:p>
           <a:p>
-            <a:pPr indent="0" marL="0">
+            <a:pPr marL="0" indent="0">
               <a:lnSpc>
                 <a:spcPct val="140000"/>
               </a:lnSpc>
@@ -1868,7 +1629,7 @@
             <a:endParaRPr lang="en-US" sz="1300" dirty="0"/>
           </a:p>
           <a:p>
-            <a:pPr indent="0" marL="0">
+            <a:pPr marL="0" indent="0">
               <a:lnSpc>
                 <a:spcPct val="140000"/>
               </a:lnSpc>
@@ -1907,7 +1668,7 @@
           <a:bodyPr wrap="square" lIns="0" tIns="0" rIns="0" bIns="0" rtlCol="0" anchor="ctr"/>
           <a:lstStyle/>
           <a:p>
-            <a:pPr indent="0" marL="0">
+            <a:pPr marL="0" indent="0">
               <a:buNone/>
             </a:pPr>
             <a:r>
@@ -1938,6 +1699,7 @@
         <a:solidFill>
           <a:srgbClr val="1A1A2E"/>
         </a:solidFill>
+        <a:effectLst/>
       </p:bgPr>
     </p:bg>
     <p:spTree>
@@ -1978,6 +1740,13 @@
             <a:prstDash val="solid"/>
           </a:ln>
         </p:spPr>
+        <p:txBody>
+          <a:bodyPr/>
+          <a:lstStyle/>
+          <a:p>
+            <a:endParaRPr lang="en-US"/>
+          </a:p>
+        </p:txBody>
       </p:sp>
       <p:sp>
         <p:nvSpPr>
@@ -2000,7 +1769,7 @@
           <a:bodyPr wrap="square" lIns="0" tIns="0" rIns="0" bIns="0" rtlCol="0" anchor="ctr"/>
           <a:lstStyle/>
           <a:p>
-            <a:pPr indent="0" marL="0">
+            <a:pPr marL="0" indent="0">
               <a:buNone/>
             </a:pPr>
             <a:r>
@@ -2036,7 +1805,7 @@
           <a:bodyPr wrap="square" lIns="0" tIns="0" rIns="0" bIns="0" rtlCol="0" anchor="ctr"/>
           <a:lstStyle/>
           <a:p>
-            <a:pPr indent="0" marL="0">
+            <a:pPr marL="0" indent="0">
               <a:buNone/>
             </a:pPr>
             <a:r>
@@ -2072,7 +1841,7 @@
           <a:bodyPr wrap="square" lIns="0" tIns="0" rIns="0" bIns="0" rtlCol="0" anchor="ctr"/>
           <a:lstStyle/>
           <a:p>
-            <a:pPr indent="0" marL="0">
+            <a:pPr marL="0" indent="0">
               <a:buNone/>
             </a:pPr>
             <a:r>
@@ -2083,9 +1852,6 @@
               </a:rPr>
               <a:t>→  </a:t>
             </a:r>
-            <a:pPr indent="0" marL="0">
-              <a:buNone/>
-            </a:pPr>
             <a:r>
               <a:rPr lang="en-US" sz="950" dirty="0">
                 <a:solidFill>
@@ -2119,7 +1885,7 @@
           <a:bodyPr wrap="square" lIns="0" tIns="0" rIns="0" bIns="0" rtlCol="0" anchor="ctr"/>
           <a:lstStyle/>
           <a:p>
-            <a:pPr indent="0" marL="0">
+            <a:pPr marL="0" indent="0">
               <a:buNone/>
             </a:pPr>
             <a:r>
@@ -2130,9 +1896,6 @@
               </a:rPr>
               <a:t>→  </a:t>
             </a:r>
-            <a:pPr indent="0" marL="0">
-              <a:buNone/>
-            </a:pPr>
             <a:r>
               <a:rPr lang="en-US" sz="950" dirty="0">
                 <a:solidFill>
@@ -2166,7 +1929,7 @@
           <a:bodyPr wrap="square" lIns="0" tIns="0" rIns="0" bIns="0" rtlCol="0" anchor="ctr"/>
           <a:lstStyle/>
           <a:p>
-            <a:pPr indent="0" marL="0">
+            <a:pPr marL="0" indent="0">
               <a:buNone/>
             </a:pPr>
             <a:r>
@@ -2177,9 +1940,6 @@
               </a:rPr>
               <a:t>→  </a:t>
             </a:r>
-            <a:pPr indent="0" marL="0">
-              <a:buNone/>
-            </a:pPr>
             <a:r>
               <a:rPr lang="en-US" sz="950" dirty="0">
                 <a:solidFill>
@@ -2213,7 +1973,7 @@
           <a:bodyPr wrap="square" lIns="0" tIns="0" rIns="0" bIns="0" rtlCol="0" anchor="ctr"/>
           <a:lstStyle/>
           <a:p>
-            <a:pPr indent="0" marL="0">
+            <a:pPr marL="0" indent="0">
               <a:buNone/>
             </a:pPr>
             <a:r>
@@ -2224,9 +1984,6 @@
               </a:rPr>
               <a:t>→  </a:t>
             </a:r>
-            <a:pPr indent="0" marL="0">
-              <a:buNone/>
-            </a:pPr>
             <a:r>
               <a:rPr lang="en-US" sz="950" dirty="0">
                 <a:solidFill>
@@ -2260,7 +2017,7 @@
           <a:bodyPr wrap="square" lIns="0" tIns="0" rIns="0" bIns="0" rtlCol="0" anchor="ctr"/>
           <a:lstStyle/>
           <a:p>
-            <a:pPr indent="0" marL="0">
+            <a:pPr marL="0" indent="0">
               <a:buNone/>
             </a:pPr>
             <a:r>
@@ -2271,9 +2028,6 @@
               </a:rPr>
               <a:t>→  </a:t>
             </a:r>
-            <a:pPr indent="0" marL="0">
-              <a:buNone/>
-            </a:pPr>
             <a:r>
               <a:rPr lang="en-US" sz="950" dirty="0">
                 <a:solidFill>
@@ -2307,7 +2061,7 @@
           <a:bodyPr wrap="square" lIns="0" tIns="0" rIns="0" bIns="0" rtlCol="0" anchor="ctr"/>
           <a:lstStyle/>
           <a:p>
-            <a:pPr indent="0" marL="0">
+            <a:pPr marL="0" indent="0">
               <a:buNone/>
             </a:pPr>
             <a:r>
@@ -2343,7 +2097,7 @@
           <a:bodyPr wrap="square" lIns="0" tIns="0" rIns="0" bIns="0" rtlCol="0" anchor="ctr"/>
           <a:lstStyle/>
           <a:p>
-            <a:pPr indent="0" marL="0">
+            <a:pPr marL="0" indent="0">
               <a:buNone/>
             </a:pPr>
             <a:r>
@@ -2354,9 +2108,6 @@
               </a:rPr>
               <a:t>→  </a:t>
             </a:r>
-            <a:pPr indent="0" marL="0">
-              <a:buNone/>
-            </a:pPr>
             <a:r>
               <a:rPr lang="en-US" sz="950" dirty="0">
                 <a:solidFill>
@@ -2390,7 +2141,7 @@
           <a:bodyPr wrap="square" lIns="0" tIns="0" rIns="0" bIns="0" rtlCol="0" anchor="ctr"/>
           <a:lstStyle/>
           <a:p>
-            <a:pPr indent="0" marL="0">
+            <a:pPr marL="0" indent="0">
               <a:buNone/>
             </a:pPr>
             <a:r>
@@ -2401,9 +2152,6 @@
               </a:rPr>
               <a:t>→  </a:t>
             </a:r>
-            <a:pPr indent="0" marL="0">
-              <a:buNone/>
-            </a:pPr>
             <a:r>
               <a:rPr lang="en-US" sz="950" dirty="0">
                 <a:solidFill>
@@ -2437,7 +2185,7 @@
           <a:bodyPr wrap="square" lIns="0" tIns="0" rIns="0" bIns="0" rtlCol="0" anchor="ctr"/>
           <a:lstStyle/>
           <a:p>
-            <a:pPr indent="0" marL="0">
+            <a:pPr marL="0" indent="0">
               <a:buNone/>
             </a:pPr>
             <a:r>
@@ -2448,9 +2196,6 @@
               </a:rPr>
               <a:t>→  </a:t>
             </a:r>
-            <a:pPr indent="0" marL="0">
-              <a:buNone/>
-            </a:pPr>
             <a:r>
               <a:rPr lang="en-US" sz="950" dirty="0">
                 <a:solidFill>
@@ -2484,7 +2229,7 @@
           <a:bodyPr wrap="square" lIns="0" tIns="0" rIns="0" bIns="0" rtlCol="0" anchor="ctr"/>
           <a:lstStyle/>
           <a:p>
-            <a:pPr indent="0" marL="0">
+            <a:pPr marL="0" indent="0">
               <a:buNone/>
             </a:pPr>
             <a:r>
@@ -2495,9 +2240,6 @@
               </a:rPr>
               <a:t>→  </a:t>
             </a:r>
-            <a:pPr indent="0" marL="0">
-              <a:buNone/>
-            </a:pPr>
             <a:r>
               <a:rPr lang="en-US" sz="950" dirty="0">
                 <a:solidFill>
@@ -2531,7 +2273,7 @@
           <a:bodyPr wrap="square" lIns="0" tIns="0" rIns="0" bIns="0" rtlCol="0" anchor="ctr"/>
           <a:lstStyle/>
           <a:p>
-            <a:pPr indent="0" marL="0">
+            <a:pPr marL="0" indent="0">
               <a:buNone/>
             </a:pPr>
             <a:r>
@@ -2542,9 +2284,6 @@
               </a:rPr>
               <a:t>→  </a:t>
             </a:r>
-            <a:pPr indent="0" marL="0">
-              <a:buNone/>
-            </a:pPr>
             <a:r>
               <a:rPr lang="en-US" sz="950" dirty="0">
                 <a:solidFill>
@@ -2581,6 +2320,13 @@
             <a:prstDash val="solid"/>
           </a:ln>
         </p:spPr>
+        <p:txBody>
+          <a:bodyPr/>
+          <a:lstStyle/>
+          <a:p>
+            <a:endParaRPr lang="en-US"/>
+          </a:p>
+        </p:txBody>
       </p:sp>
       <p:sp>
         <p:nvSpPr>
@@ -2603,16 +2349,70 @@
           <a:bodyPr wrap="square" lIns="0" tIns="0" rIns="0" bIns="0" rtlCol="0" anchor="ctr"/>
           <a:lstStyle/>
           <a:p>
-            <a:pPr algn="ctr" indent="0" marL="0">
-              <a:buNone/>
-            </a:pPr>
+            <a:pPr algn="ctr"/>
             <a:r>
               <a:rPr lang="en-US" sz="1000" dirty="0">
                 <a:solidFill>
                   <a:srgbClr val="FFFFFF"/>
                 </a:solidFill>
               </a:rPr>
-              <a:t>Streamlit UI: localhost:8501  |  All computation in PySpark  |  GitHub: ITToday/ddos-bigdata-project</a:t>
+              <a:t>Streamlit UI: localhost:8501  |  All computation in PySpark  |  GitHub: https://</a:t>
+            </a:r>
+            <a:r>
+              <a:rPr lang="en-US" sz="1000" dirty="0" err="1">
+                <a:solidFill>
+                  <a:srgbClr val="FFFFFF"/>
+                </a:solidFill>
+              </a:rPr>
+              <a:t>github.com</a:t>
+            </a:r>
+            <a:r>
+              <a:rPr lang="en-US" sz="1000" dirty="0">
+                <a:solidFill>
+                  <a:srgbClr val="FFFFFF"/>
+                </a:solidFill>
+              </a:rPr>
+              <a:t>/</a:t>
+            </a:r>
+            <a:r>
+              <a:rPr lang="en-US" sz="1000" dirty="0" err="1">
+                <a:solidFill>
+                  <a:srgbClr val="FFFFFF"/>
+                </a:solidFill>
+              </a:rPr>
+              <a:t>ITToday</a:t>
+            </a:r>
+            <a:r>
+              <a:rPr lang="en-US" sz="1000" dirty="0">
+                <a:solidFill>
+                  <a:srgbClr val="FFFFFF"/>
+                </a:solidFill>
+              </a:rPr>
+              <a:t>/</a:t>
+            </a:r>
+            <a:r>
+              <a:rPr lang="en-US" sz="1000" dirty="0" err="1">
+                <a:solidFill>
+                  <a:srgbClr val="FFFFFF"/>
+                </a:solidFill>
+              </a:rPr>
+              <a:t>ddos</a:t>
+            </a:r>
+            <a:r>
+              <a:rPr lang="en-US" sz="1000" dirty="0">
+                <a:solidFill>
+                  <a:srgbClr val="FFFFFF"/>
+                </a:solidFill>
+              </a:rPr>
+              <a:t>-bigdata-</a:t>
+            </a:r>
+            <a:r>
+              <a:rPr lang="en-US" sz="1000" dirty="0" err="1">
+                <a:solidFill>
+                  <a:srgbClr val="FFFFFF"/>
+                </a:solidFill>
+              </a:rPr>
+              <a:t>project.git</a:t>
             </a:r>
             <a:endParaRPr lang="en-US" sz="1000" dirty="0"/>
           </a:p>
@@ -2634,6 +2434,7 @@
         <a:solidFill>
           <a:srgbClr val="F8F9FC"/>
         </a:solidFill>
+        <a:effectLst/>
       </p:bgPr>
     </p:bg>
     <p:spTree>
@@ -2674,6 +2475,13 @@
             <a:prstDash val="solid"/>
           </a:ln>
         </p:spPr>
+        <p:txBody>
+          <a:bodyPr/>
+          <a:lstStyle/>
+          <a:p>
+            <a:endParaRPr lang="en-US"/>
+          </a:p>
+        </p:txBody>
       </p:sp>
       <p:sp>
         <p:nvSpPr>
@@ -2696,7 +2504,7 @@
           <a:bodyPr wrap="square" lIns="0" tIns="0" rIns="0" bIns="0" rtlCol="0" anchor="ctr"/>
           <a:lstStyle/>
           <a:p>
-            <a:pPr algn="l" indent="0" marL="0">
+            <a:pPr marL="0" indent="0" algn="l">
               <a:buNone/>
             </a:pPr>
             <a:r>
@@ -2732,7 +2540,7 @@
           <a:bodyPr wrap="square" lIns="0" tIns="0" rIns="0" bIns="0" rtlCol="0" anchor="ctr"/>
           <a:lstStyle/>
           <a:p>
-            <a:pPr indent="0" marL="0">
+            <a:pPr marL="0" indent="0">
               <a:buNone/>
             </a:pPr>
             <a:r>
@@ -2768,7 +2576,7 @@
           <a:bodyPr wrap="square" lIns="0" tIns="0" rIns="0" bIns="0" rtlCol="0" anchor="ctr"/>
           <a:lstStyle/>
           <a:p>
-            <a:pPr indent="0" marL="0">
+            <a:pPr marL="0" indent="0">
               <a:lnSpc>
                 <a:spcPct val="135000"/>
               </a:lnSpc>
@@ -2785,7 +2593,7 @@
             <a:endParaRPr lang="en-US" sz="1100" dirty="0"/>
           </a:p>
           <a:p>
-            <a:pPr indent="0" marL="0">
+            <a:pPr marL="0" indent="0">
               <a:lnSpc>
                 <a:spcPct val="135000"/>
               </a:lnSpc>
@@ -2802,7 +2610,7 @@
             <a:endParaRPr lang="en-US" sz="1100" dirty="0"/>
           </a:p>
           <a:p>
-            <a:pPr indent="0" marL="0">
+            <a:pPr marL="0" indent="0">
               <a:lnSpc>
                 <a:spcPct val="135000"/>
               </a:lnSpc>
@@ -2819,7 +2627,7 @@
             <a:endParaRPr lang="en-US" sz="1100" dirty="0"/>
           </a:p>
           <a:p>
-            <a:pPr indent="0" marL="0">
+            <a:pPr marL="0" indent="0">
               <a:lnSpc>
                 <a:spcPct val="135000"/>
               </a:lnSpc>
@@ -2836,7 +2644,7 @@
             <a:endParaRPr lang="en-US" sz="1100" dirty="0"/>
           </a:p>
           <a:p>
-            <a:pPr indent="0" marL="0">
+            <a:pPr marL="0" indent="0">
               <a:lnSpc>
                 <a:spcPct val="135000"/>
               </a:lnSpc>
@@ -2853,7 +2661,7 @@
             <a:endParaRPr lang="en-US" sz="1100" dirty="0"/>
           </a:p>
           <a:p>
-            <a:pPr indent="0" marL="0">
+            <a:pPr marL="0" indent="0">
               <a:lnSpc>
                 <a:spcPct val="135000"/>
               </a:lnSpc>
@@ -2870,7 +2678,7 @@
             <a:endParaRPr lang="en-US" sz="1100" dirty="0"/>
           </a:p>
           <a:p>
-            <a:pPr indent="0" marL="0">
+            <a:pPr marL="0" indent="0">
               <a:lnSpc>
                 <a:spcPct val="135000"/>
               </a:lnSpc>
@@ -2887,7 +2695,7 @@
             <a:endParaRPr lang="en-US" sz="1100" dirty="0"/>
           </a:p>
           <a:p>
-            <a:pPr indent="0" marL="0">
+            <a:pPr marL="0" indent="0">
               <a:lnSpc>
                 <a:spcPct val="135000"/>
               </a:lnSpc>
@@ -2904,7 +2712,7 @@
             <a:endParaRPr lang="en-US" sz="1100" dirty="0"/>
           </a:p>
           <a:p>
-            <a:pPr indent="0" marL="0">
+            <a:pPr marL="0" indent="0">
               <a:lnSpc>
                 <a:spcPct val="135000"/>
               </a:lnSpc>
@@ -2921,7 +2729,7 @@
             <a:endParaRPr lang="en-US" sz="1100" dirty="0"/>
           </a:p>
           <a:p>
-            <a:pPr indent="0" marL="0">
+            <a:pPr marL="0" indent="0">
               <a:lnSpc>
                 <a:spcPct val="135000"/>
               </a:lnSpc>
@@ -2961,6 +2769,13 @@
             <a:prstDash val="solid"/>
           </a:ln>
         </p:spPr>
+        <p:txBody>
+          <a:bodyPr/>
+          <a:lstStyle/>
+          <a:p>
+            <a:endParaRPr lang="en-US"/>
+          </a:p>
+        </p:txBody>
       </p:sp>
       <p:sp>
         <p:nvSpPr>
@@ -2983,7 +2798,7 @@
           <a:bodyPr wrap="square" lIns="0" tIns="0" rIns="0" bIns="0" rtlCol="0" anchor="ctr"/>
           <a:lstStyle/>
           <a:p>
-            <a:pPr indent="0" marL="0">
+            <a:pPr marL="0" indent="0">
               <a:buNone/>
             </a:pPr>
             <a:r>
@@ -3019,7 +2834,7 @@
           <a:bodyPr wrap="square" lIns="0" tIns="0" rIns="0" bIns="0" rtlCol="0" anchor="ctr"/>
           <a:lstStyle/>
           <a:p>
-            <a:pPr indent="0" marL="0">
+            <a:pPr marL="0" indent="0">
               <a:lnSpc>
                 <a:spcPct val="135000"/>
               </a:lnSpc>
@@ -3036,7 +2851,7 @@
             <a:endParaRPr lang="en-US" sz="1100" dirty="0"/>
           </a:p>
           <a:p>
-            <a:pPr indent="0" marL="0">
+            <a:pPr marL="0" indent="0">
               <a:lnSpc>
                 <a:spcPct val="135000"/>
               </a:lnSpc>
@@ -3053,7 +2868,7 @@
             <a:endParaRPr lang="en-US" sz="1100" dirty="0"/>
           </a:p>
           <a:p>
-            <a:pPr indent="0" marL="0">
+            <a:pPr marL="0" indent="0">
               <a:lnSpc>
                 <a:spcPct val="135000"/>
               </a:lnSpc>
@@ -3070,7 +2885,7 @@
             <a:endParaRPr lang="en-US" sz="1100" dirty="0"/>
           </a:p>
           <a:p>
-            <a:pPr indent="0" marL="0">
+            <a:pPr marL="0" indent="0">
               <a:lnSpc>
                 <a:spcPct val="135000"/>
               </a:lnSpc>
@@ -3087,7 +2902,7 @@
             <a:endParaRPr lang="en-US" sz="1100" dirty="0"/>
           </a:p>
           <a:p>
-            <a:pPr indent="0" marL="0">
+            <a:pPr marL="0" indent="0">
               <a:lnSpc>
                 <a:spcPct val="135000"/>
               </a:lnSpc>
@@ -3104,7 +2919,7 @@
             <a:endParaRPr lang="en-US" sz="1100" dirty="0"/>
           </a:p>
           <a:p>
-            <a:pPr indent="0" marL="0">
+            <a:pPr marL="0" indent="0">
               <a:lnSpc>
                 <a:spcPct val="135000"/>
               </a:lnSpc>
@@ -3121,7 +2936,7 @@
             <a:endParaRPr lang="en-US" sz="1100" dirty="0"/>
           </a:p>
           <a:p>
-            <a:pPr indent="0" marL="0">
+            <a:pPr marL="0" indent="0">
               <a:lnSpc>
                 <a:spcPct val="135000"/>
               </a:lnSpc>
@@ -3138,7 +2953,7 @@
             <a:endParaRPr lang="en-US" sz="1100" dirty="0"/>
           </a:p>
           <a:p>
-            <a:pPr indent="0" marL="0">
+            <a:pPr marL="0" indent="0">
               <a:lnSpc>
                 <a:spcPct val="135000"/>
               </a:lnSpc>
@@ -3172,6 +2987,7 @@
         <a:solidFill>
           <a:srgbClr val="F8F9FC"/>
         </a:solidFill>
+        <a:effectLst/>
       </p:bgPr>
     </p:bg>
     <p:spTree>
@@ -3212,6 +3028,13 @@
             <a:prstDash val="solid"/>
           </a:ln>
         </p:spPr>
+        <p:txBody>
+          <a:bodyPr/>
+          <a:lstStyle/>
+          <a:p>
+            <a:endParaRPr lang="en-US"/>
+          </a:p>
+        </p:txBody>
       </p:sp>
       <p:sp>
         <p:nvSpPr>
@@ -3234,7 +3057,7 @@
           <a:bodyPr wrap="square" lIns="0" tIns="0" rIns="0" bIns="0" rtlCol="0" anchor="ctr"/>
           <a:lstStyle/>
           <a:p>
-            <a:pPr algn="l" indent="0" marL="0">
+            <a:pPr marL="0" indent="0" algn="l">
               <a:buNone/>
             </a:pPr>
             <a:r>
@@ -3270,7 +3093,7 @@
           <a:bodyPr wrap="square" lIns="0" tIns="0" rIns="0" bIns="0" rtlCol="0" anchor="ctr"/>
           <a:lstStyle/>
           <a:p>
-            <a:pPr indent="0" marL="0">
+            <a:pPr marL="0" indent="0">
               <a:buNone/>
             </a:pPr>
             <a:r>
@@ -3309,6 +3132,13 @@
             <a:prstDash val="solid"/>
           </a:ln>
         </p:spPr>
+        <p:txBody>
+          <a:bodyPr/>
+          <a:lstStyle/>
+          <a:p>
+            <a:endParaRPr lang="en-US"/>
+          </a:p>
+        </p:txBody>
       </p:sp>
       <p:sp>
         <p:nvSpPr>
@@ -3331,7 +3161,7 @@
           <a:bodyPr wrap="square" lIns="0" tIns="0" rIns="0" bIns="0" rtlCol="0" anchor="ctr"/>
           <a:lstStyle/>
           <a:p>
-            <a:pPr algn="ctr" indent="0" marL="0">
+            <a:pPr marL="0" indent="0" algn="ctr">
               <a:buNone/>
             </a:pPr>
             <a:r>
@@ -3367,7 +3197,7 @@
           <a:bodyPr wrap="square" lIns="0" tIns="0" rIns="0" bIns="0" rtlCol="0" anchor="ctr"/>
           <a:lstStyle/>
           <a:p>
-            <a:pPr indent="0" marL="0">
+            <a:pPr marL="0" indent="0">
               <a:buNone/>
             </a:pPr>
             <a:r>
@@ -3406,6 +3236,13 @@
             <a:prstDash val="solid"/>
           </a:ln>
         </p:spPr>
+        <p:txBody>
+          <a:bodyPr/>
+          <a:lstStyle/>
+          <a:p>
+            <a:endParaRPr lang="en-US"/>
+          </a:p>
+        </p:txBody>
       </p:sp>
       <p:sp>
         <p:nvSpPr>
@@ -3428,7 +3265,7 @@
           <a:bodyPr wrap="square" lIns="0" tIns="0" rIns="0" bIns="0" rtlCol="0" anchor="ctr"/>
           <a:lstStyle/>
           <a:p>
-            <a:pPr algn="ctr" indent="0" marL="0">
+            <a:pPr marL="0" indent="0" algn="ctr">
               <a:buNone/>
             </a:pPr>
             <a:r>
@@ -3464,7 +3301,7 @@
           <a:bodyPr wrap="square" lIns="0" tIns="0" rIns="0" bIns="0" rtlCol="0" anchor="ctr"/>
           <a:lstStyle/>
           <a:p>
-            <a:pPr indent="0" marL="0">
+            <a:pPr marL="0" indent="0">
               <a:buNone/>
             </a:pPr>
             <a:r>
@@ -3503,6 +3340,13 @@
             <a:prstDash val="solid"/>
           </a:ln>
         </p:spPr>
+        <p:txBody>
+          <a:bodyPr/>
+          <a:lstStyle/>
+          <a:p>
+            <a:endParaRPr lang="en-US"/>
+          </a:p>
+        </p:txBody>
       </p:sp>
       <p:sp>
         <p:nvSpPr>
@@ -3525,7 +3369,7 @@
           <a:bodyPr wrap="square" lIns="0" tIns="0" rIns="0" bIns="0" rtlCol="0" anchor="ctr"/>
           <a:lstStyle/>
           <a:p>
-            <a:pPr algn="ctr" indent="0" marL="0">
+            <a:pPr marL="0" indent="0" algn="ctr">
               <a:buNone/>
             </a:pPr>
             <a:r>
@@ -3561,7 +3405,7 @@
           <a:bodyPr wrap="square" lIns="0" tIns="0" rIns="0" bIns="0" rtlCol="0" anchor="ctr"/>
           <a:lstStyle/>
           <a:p>
-            <a:pPr indent="0" marL="0">
+            <a:pPr marL="0" indent="0">
               <a:buNone/>
             </a:pPr>
             <a:r>
@@ -3600,6 +3444,13 @@
             <a:prstDash val="solid"/>
           </a:ln>
         </p:spPr>
+        <p:txBody>
+          <a:bodyPr/>
+          <a:lstStyle/>
+          <a:p>
+            <a:endParaRPr lang="en-US"/>
+          </a:p>
+        </p:txBody>
       </p:sp>
       <p:sp>
         <p:nvSpPr>
@@ -3622,7 +3473,7 @@
           <a:bodyPr wrap="square" lIns="0" tIns="0" rIns="0" bIns="0" rtlCol="0" anchor="ctr"/>
           <a:lstStyle/>
           <a:p>
-            <a:pPr algn="ctr" indent="0" marL="0">
+            <a:pPr marL="0" indent="0" algn="ctr">
               <a:buNone/>
             </a:pPr>
             <a:r>
@@ -3658,7 +3509,7 @@
           <a:bodyPr wrap="square" lIns="0" tIns="0" rIns="0" bIns="0" rtlCol="0" anchor="ctr"/>
           <a:lstStyle/>
           <a:p>
-            <a:pPr indent="0" marL="0">
+            <a:pPr marL="0" indent="0">
               <a:buNone/>
             </a:pPr>
             <a:r>
@@ -3697,6 +3548,13 @@
             <a:prstDash val="solid"/>
           </a:ln>
         </p:spPr>
+        <p:txBody>
+          <a:bodyPr/>
+          <a:lstStyle/>
+          <a:p>
+            <a:endParaRPr lang="en-US"/>
+          </a:p>
+        </p:txBody>
       </p:sp>
       <p:sp>
         <p:nvSpPr>
@@ -3719,7 +3577,7 @@
           <a:bodyPr wrap="square" lIns="0" tIns="0" rIns="0" bIns="0" rtlCol="0" anchor="ctr"/>
           <a:lstStyle/>
           <a:p>
-            <a:pPr algn="ctr" indent="0" marL="0">
+            <a:pPr marL="0" indent="0" algn="ctr">
               <a:buNone/>
             </a:pPr>
             <a:r>
@@ -3755,7 +3613,7 @@
           <a:bodyPr wrap="square" lIns="0" tIns="0" rIns="0" bIns="0" rtlCol="0" anchor="ctr"/>
           <a:lstStyle/>
           <a:p>
-            <a:pPr indent="0" marL="0">
+            <a:pPr marL="0" indent="0">
               <a:buNone/>
             </a:pPr>
             <a:r>
@@ -3794,6 +3652,13 @@
             <a:prstDash val="solid"/>
           </a:ln>
         </p:spPr>
+        <p:txBody>
+          <a:bodyPr/>
+          <a:lstStyle/>
+          <a:p>
+            <a:endParaRPr lang="en-US"/>
+          </a:p>
+        </p:txBody>
       </p:sp>
       <p:sp>
         <p:nvSpPr>
@@ -3816,7 +3681,7 @@
           <a:bodyPr wrap="square" lIns="0" tIns="0" rIns="0" bIns="0" rtlCol="0" anchor="ctr"/>
           <a:lstStyle/>
           <a:p>
-            <a:pPr algn="ctr" indent="0" marL="0">
+            <a:pPr marL="0" indent="0" algn="ctr">
               <a:buNone/>
             </a:pPr>
             <a:r>
@@ -3852,7 +3717,7 @@
           <a:bodyPr wrap="square" lIns="0" tIns="0" rIns="0" bIns="0" rtlCol="0" anchor="ctr"/>
           <a:lstStyle/>
           <a:p>
-            <a:pPr indent="0" marL="0">
+            <a:pPr marL="0" indent="0">
               <a:buNone/>
             </a:pPr>
             <a:r>
@@ -3891,6 +3756,13 @@
             <a:prstDash val="solid"/>
           </a:ln>
         </p:spPr>
+        <p:txBody>
+          <a:bodyPr/>
+          <a:lstStyle/>
+          <a:p>
+            <a:endParaRPr lang="en-US"/>
+          </a:p>
+        </p:txBody>
       </p:sp>
       <p:sp>
         <p:nvSpPr>
@@ -3913,7 +3785,7 @@
           <a:bodyPr wrap="square" lIns="0" tIns="0" rIns="0" bIns="0" rtlCol="0" anchor="ctr"/>
           <a:lstStyle/>
           <a:p>
-            <a:pPr algn="ctr" indent="0" marL="0">
+            <a:pPr marL="0" indent="0" algn="ctr">
               <a:buNone/>
             </a:pPr>
             <a:r>
@@ -3949,7 +3821,7 @@
           <a:bodyPr wrap="square" lIns="0" tIns="0" rIns="0" bIns="0" rtlCol="0" anchor="ctr"/>
           <a:lstStyle/>
           <a:p>
-            <a:pPr indent="0" marL="0">
+            <a:pPr marL="0" indent="0">
               <a:buNone/>
             </a:pPr>
             <a:r>
@@ -3988,6 +3860,13 @@
             <a:prstDash val="solid"/>
           </a:ln>
         </p:spPr>
+        <p:txBody>
+          <a:bodyPr/>
+          <a:lstStyle/>
+          <a:p>
+            <a:endParaRPr lang="en-US"/>
+          </a:p>
+        </p:txBody>
       </p:sp>
       <p:sp>
         <p:nvSpPr>
@@ -4010,7 +3889,7 @@
           <a:bodyPr wrap="square" lIns="0" tIns="0" rIns="0" bIns="0" rtlCol="0" anchor="ctr"/>
           <a:lstStyle/>
           <a:p>
-            <a:pPr algn="ctr" indent="0" marL="0">
+            <a:pPr marL="0" indent="0" algn="ctr">
               <a:buNone/>
             </a:pPr>
             <a:r>
@@ -4046,7 +3925,7 @@
           <a:bodyPr wrap="square" lIns="0" tIns="0" rIns="0" bIns="0" rtlCol="0" anchor="ctr"/>
           <a:lstStyle/>
           <a:p>
-            <a:pPr indent="0" marL="0">
+            <a:pPr marL="0" indent="0">
               <a:buNone/>
             </a:pPr>
             <a:r>
@@ -4082,7 +3961,7 @@
           <a:bodyPr wrap="square" lIns="0" tIns="0" rIns="0" bIns="0" rtlCol="0" anchor="ctr"/>
           <a:lstStyle/>
           <a:p>
-            <a:pPr indent="0" marL="0">
+            <a:pPr marL="0" indent="0">
               <a:buNone/>
             </a:pPr>
             <a:r>
@@ -4116,13 +3995,20 @@
           </a:solidFill>
           <a:ln/>
           <a:effectLst>
-            <a:outerShdw sx="100000" sy="100000" kx="0" ky="0" algn="bl" rotWithShape="0" blurRad="50800" dist="12700" dir="8100000">
+            <a:outerShdw blurRad="50800" dist="12700" dir="8100000" algn="bl" rotWithShape="0">
               <a:srgbClr val="000000">
                 <a:alpha val="12000"/>
               </a:srgbClr>
             </a:outerShdw>
           </a:effectLst>
         </p:spPr>
+        <p:txBody>
+          <a:bodyPr/>
+          <a:lstStyle/>
+          <a:p>
+            <a:endParaRPr lang="en-US"/>
+          </a:p>
+        </p:txBody>
       </p:sp>
       <p:sp>
         <p:nvSpPr>
@@ -4145,7 +4031,7 @@
           <a:bodyPr wrap="square" lIns="0" tIns="0" rIns="0" bIns="0" rtlCol="0" anchor="ctr"/>
           <a:lstStyle/>
           <a:p>
-            <a:pPr indent="0" marL="0">
+            <a:pPr marL="0" indent="0">
               <a:buNone/>
             </a:pPr>
             <a:r>
@@ -4181,7 +4067,7 @@
           <a:bodyPr wrap="square" lIns="0" tIns="0" rIns="0" bIns="0" rtlCol="0" anchor="ctr"/>
           <a:lstStyle/>
           <a:p>
-            <a:pPr indent="0" marL="0">
+            <a:pPr marL="0" indent="0">
               <a:buNone/>
             </a:pPr>
             <a:r>
@@ -4218,6 +4104,13 @@
             <a:prstDash val="solid"/>
           </a:ln>
         </p:spPr>
+        <p:txBody>
+          <a:bodyPr/>
+          <a:lstStyle/>
+          <a:p>
+            <a:endParaRPr lang="en-US"/>
+          </a:p>
+        </p:txBody>
       </p:sp>
       <p:sp>
         <p:nvSpPr>
@@ -4238,13 +4131,20 @@
           </a:solidFill>
           <a:ln/>
           <a:effectLst>
-            <a:outerShdw sx="100000" sy="100000" kx="0" ky="0" algn="bl" rotWithShape="0" blurRad="50800" dist="12700" dir="8100000">
+            <a:outerShdw blurRad="50800" dist="12700" dir="8100000" algn="bl" rotWithShape="0">
               <a:srgbClr val="000000">
                 <a:alpha val="12000"/>
               </a:srgbClr>
             </a:outerShdw>
           </a:effectLst>
         </p:spPr>
+        <p:txBody>
+          <a:bodyPr/>
+          <a:lstStyle/>
+          <a:p>
+            <a:endParaRPr lang="en-US"/>
+          </a:p>
+        </p:txBody>
       </p:sp>
       <p:sp>
         <p:nvSpPr>
@@ -4267,7 +4167,7 @@
           <a:bodyPr wrap="square" lIns="0" tIns="0" rIns="0" bIns="0" rtlCol="0" anchor="ctr"/>
           <a:lstStyle/>
           <a:p>
-            <a:pPr indent="0" marL="0">
+            <a:pPr marL="0" indent="0">
               <a:buNone/>
             </a:pPr>
             <a:r>
@@ -4303,7 +4203,7 @@
           <a:bodyPr wrap="square" lIns="0" tIns="0" rIns="0" bIns="0" rtlCol="0" anchor="ctr"/>
           <a:lstStyle/>
           <a:p>
-            <a:pPr indent="0" marL="0">
+            <a:pPr marL="0" indent="0">
               <a:buNone/>
             </a:pPr>
             <a:r>
@@ -4340,6 +4240,13 @@
             <a:prstDash val="solid"/>
           </a:ln>
         </p:spPr>
+        <p:txBody>
+          <a:bodyPr/>
+          <a:lstStyle/>
+          <a:p>
+            <a:endParaRPr lang="en-US"/>
+          </a:p>
+        </p:txBody>
       </p:sp>
       <p:sp>
         <p:nvSpPr>
@@ -4360,13 +4267,20 @@
           </a:solidFill>
           <a:ln/>
           <a:effectLst>
-            <a:outerShdw sx="100000" sy="100000" kx="0" ky="0" algn="bl" rotWithShape="0" blurRad="50800" dist="12700" dir="8100000">
+            <a:outerShdw blurRad="50800" dist="12700" dir="8100000" algn="bl" rotWithShape="0">
               <a:srgbClr val="000000">
                 <a:alpha val="12000"/>
               </a:srgbClr>
             </a:outerShdw>
           </a:effectLst>
         </p:spPr>
+        <p:txBody>
+          <a:bodyPr/>
+          <a:lstStyle/>
+          <a:p>
+            <a:endParaRPr lang="en-US"/>
+          </a:p>
+        </p:txBody>
       </p:sp>
       <p:sp>
         <p:nvSpPr>
@@ -4389,7 +4303,7 @@
           <a:bodyPr wrap="square" lIns="0" tIns="0" rIns="0" bIns="0" rtlCol="0" anchor="ctr"/>
           <a:lstStyle/>
           <a:p>
-            <a:pPr indent="0" marL="0">
+            <a:pPr marL="0" indent="0">
               <a:buNone/>
             </a:pPr>
             <a:r>
@@ -4425,7 +4339,7 @@
           <a:bodyPr wrap="square" lIns="0" tIns="0" rIns="0" bIns="0" rtlCol="0" anchor="ctr"/>
           <a:lstStyle/>
           <a:p>
-            <a:pPr indent="0" marL="0">
+            <a:pPr marL="0" indent="0">
               <a:buNone/>
             </a:pPr>
             <a:r>
@@ -4462,6 +4376,13 @@
             <a:prstDash val="solid"/>
           </a:ln>
         </p:spPr>
+        <p:txBody>
+          <a:bodyPr/>
+          <a:lstStyle/>
+          <a:p>
+            <a:endParaRPr lang="en-US"/>
+          </a:p>
+        </p:txBody>
       </p:sp>
       <p:sp>
         <p:nvSpPr>
@@ -4482,13 +4403,20 @@
           </a:solidFill>
           <a:ln/>
           <a:effectLst>
-            <a:outerShdw sx="100000" sy="100000" kx="0" ky="0" algn="bl" rotWithShape="0" blurRad="50800" dist="12700" dir="8100000">
+            <a:outerShdw blurRad="50800" dist="12700" dir="8100000" algn="bl" rotWithShape="0">
               <a:srgbClr val="000000">
                 <a:alpha val="12000"/>
               </a:srgbClr>
             </a:outerShdw>
           </a:effectLst>
         </p:spPr>
+        <p:txBody>
+          <a:bodyPr/>
+          <a:lstStyle/>
+          <a:p>
+            <a:endParaRPr lang="en-US"/>
+          </a:p>
+        </p:txBody>
       </p:sp>
       <p:sp>
         <p:nvSpPr>
@@ -4511,7 +4439,7 @@
           <a:bodyPr wrap="square" lIns="0" tIns="0" rIns="0" bIns="0" rtlCol="0" anchor="ctr"/>
           <a:lstStyle/>
           <a:p>
-            <a:pPr indent="0" marL="0">
+            <a:pPr marL="0" indent="0">
               <a:buNone/>
             </a:pPr>
             <a:r>
@@ -4547,7 +4475,7 @@
           <a:bodyPr wrap="square" lIns="0" tIns="0" rIns="0" bIns="0" rtlCol="0" anchor="ctr"/>
           <a:lstStyle/>
           <a:p>
-            <a:pPr indent="0" marL="0">
+            <a:pPr marL="0" indent="0">
               <a:buNone/>
             </a:pPr>
             <a:r>
@@ -4584,6 +4512,13 @@
             <a:prstDash val="solid"/>
           </a:ln>
         </p:spPr>
+        <p:txBody>
+          <a:bodyPr/>
+          <a:lstStyle/>
+          <a:p>
+            <a:endParaRPr lang="en-US"/>
+          </a:p>
+        </p:txBody>
       </p:sp>
       <p:sp>
         <p:nvSpPr>
@@ -4604,13 +4539,20 @@
           </a:solidFill>
           <a:ln/>
           <a:effectLst>
-            <a:outerShdw sx="100000" sy="100000" kx="0" ky="0" algn="bl" rotWithShape="0" blurRad="50800" dist="12700" dir="8100000">
+            <a:outerShdw blurRad="50800" dist="12700" dir="8100000" algn="bl" rotWithShape="0">
               <a:srgbClr val="000000">
                 <a:alpha val="12000"/>
               </a:srgbClr>
             </a:outerShdw>
           </a:effectLst>
         </p:spPr>
+        <p:txBody>
+          <a:bodyPr/>
+          <a:lstStyle/>
+          <a:p>
+            <a:endParaRPr lang="en-US"/>
+          </a:p>
+        </p:txBody>
       </p:sp>
       <p:sp>
         <p:nvSpPr>
@@ -4633,7 +4575,7 @@
           <a:bodyPr wrap="square" lIns="0" tIns="0" rIns="0" bIns="0" rtlCol="0" anchor="ctr"/>
           <a:lstStyle/>
           <a:p>
-            <a:pPr indent="0" marL="0">
+            <a:pPr marL="0" indent="0">
               <a:buNone/>
             </a:pPr>
             <a:r>
@@ -4669,7 +4611,7 @@
           <a:bodyPr wrap="square" lIns="0" tIns="0" rIns="0" bIns="0" rtlCol="0" anchor="ctr"/>
           <a:lstStyle/>
           <a:p>
-            <a:pPr indent="0" marL="0">
+            <a:pPr marL="0" indent="0">
               <a:buNone/>
             </a:pPr>
             <a:r>
@@ -4700,6 +4642,7 @@
         <a:solidFill>
           <a:srgbClr val="F8F9FC"/>
         </a:solidFill>
+        <a:effectLst/>
       </p:bgPr>
     </p:bg>
     <p:spTree>
@@ -4740,6 +4683,13 @@
             <a:prstDash val="solid"/>
           </a:ln>
         </p:spPr>
+        <p:txBody>
+          <a:bodyPr/>
+          <a:lstStyle/>
+          <a:p>
+            <a:endParaRPr lang="en-US"/>
+          </a:p>
+        </p:txBody>
       </p:sp>
       <p:sp>
         <p:nvSpPr>
@@ -4762,7 +4712,7 @@
           <a:bodyPr wrap="square" lIns="0" tIns="0" rIns="0" bIns="0" rtlCol="0" anchor="ctr"/>
           <a:lstStyle/>
           <a:p>
-            <a:pPr algn="l" indent="0" marL="0">
+            <a:pPr marL="0" indent="0" algn="l">
               <a:buNone/>
             </a:pPr>
             <a:r>
@@ -4798,7 +4748,7 @@
           <a:bodyPr wrap="square" lIns="0" tIns="0" rIns="0" bIns="0" rtlCol="0" anchor="ctr"/>
           <a:lstStyle/>
           <a:p>
-            <a:pPr indent="0" marL="0">
+            <a:pPr marL="0" indent="0">
               <a:buNone/>
             </a:pPr>
             <a:r>
@@ -4832,13 +4782,20 @@
           </a:solidFill>
           <a:ln/>
           <a:effectLst>
-            <a:outerShdw sx="100000" sy="100000" kx="0" ky="0" algn="bl" rotWithShape="0" blurRad="101600" dist="25400" dir="8100000">
+            <a:outerShdw blurRad="101600" dist="25400" dir="8100000" algn="bl" rotWithShape="0">
               <a:srgbClr val="000000">
                 <a:alpha val="10000"/>
               </a:srgbClr>
             </a:outerShdw>
           </a:effectLst>
         </p:spPr>
+        <p:txBody>
+          <a:bodyPr/>
+          <a:lstStyle/>
+          <a:p>
+            <a:endParaRPr lang="en-US"/>
+          </a:p>
+        </p:txBody>
       </p:sp>
       <p:sp>
         <p:nvSpPr>
@@ -4864,6 +4821,13 @@
             <a:prstDash val="solid"/>
           </a:ln>
         </p:spPr>
+        <p:txBody>
+          <a:bodyPr/>
+          <a:lstStyle/>
+          <a:p>
+            <a:endParaRPr lang="en-US"/>
+          </a:p>
+        </p:txBody>
       </p:sp>
       <p:sp>
         <p:nvSpPr>
@@ -4886,7 +4850,7 @@
           <a:bodyPr wrap="square" lIns="0" tIns="0" rIns="0" bIns="0" rtlCol="0" anchor="ctr"/>
           <a:lstStyle/>
           <a:p>
-            <a:pPr indent="0" marL="0">
+            <a:pPr marL="0" indent="0">
               <a:buNone/>
             </a:pPr>
             <a:r>
@@ -4922,7 +4886,7 @@
           <a:bodyPr wrap="square" lIns="0" tIns="0" rIns="0" bIns="0" rtlCol="0" anchor="ctr"/>
           <a:lstStyle/>
           <a:p>
-            <a:pPr indent="0" marL="0">
+            <a:pPr marL="0" indent="0">
               <a:buNone/>
             </a:pPr>
             <a:r>
@@ -4956,13 +4920,20 @@
           </a:solidFill>
           <a:ln/>
           <a:effectLst>
-            <a:outerShdw sx="100000" sy="100000" kx="0" ky="0" algn="bl" rotWithShape="0" blurRad="101600" dist="25400" dir="8100000">
+            <a:outerShdw blurRad="101600" dist="25400" dir="8100000" algn="bl" rotWithShape="0">
               <a:srgbClr val="000000">
                 <a:alpha val="10000"/>
               </a:srgbClr>
             </a:outerShdw>
           </a:effectLst>
         </p:spPr>
+        <p:txBody>
+          <a:bodyPr/>
+          <a:lstStyle/>
+          <a:p>
+            <a:endParaRPr lang="en-US"/>
+          </a:p>
+        </p:txBody>
       </p:sp>
       <p:sp>
         <p:nvSpPr>
@@ -4988,6 +4959,13 @@
             <a:prstDash val="solid"/>
           </a:ln>
         </p:spPr>
+        <p:txBody>
+          <a:bodyPr/>
+          <a:lstStyle/>
+          <a:p>
+            <a:endParaRPr lang="en-US"/>
+          </a:p>
+        </p:txBody>
       </p:sp>
       <p:sp>
         <p:nvSpPr>
@@ -5010,7 +4988,7 @@
           <a:bodyPr wrap="square" lIns="0" tIns="0" rIns="0" bIns="0" rtlCol="0" anchor="ctr"/>
           <a:lstStyle/>
           <a:p>
-            <a:pPr indent="0" marL="0">
+            <a:pPr marL="0" indent="0">
               <a:buNone/>
             </a:pPr>
             <a:r>
@@ -5046,7 +5024,7 @@
           <a:bodyPr wrap="square" lIns="0" tIns="0" rIns="0" bIns="0" rtlCol="0" anchor="ctr"/>
           <a:lstStyle/>
           <a:p>
-            <a:pPr indent="0" marL="0">
+            <a:pPr marL="0" indent="0">
               <a:buNone/>
             </a:pPr>
             <a:r>
@@ -5080,13 +5058,20 @@
           </a:solidFill>
           <a:ln/>
           <a:effectLst>
-            <a:outerShdw sx="100000" sy="100000" kx="0" ky="0" algn="bl" rotWithShape="0" blurRad="101600" dist="25400" dir="8100000">
+            <a:outerShdw blurRad="101600" dist="25400" dir="8100000" algn="bl" rotWithShape="0">
               <a:srgbClr val="000000">
                 <a:alpha val="10000"/>
               </a:srgbClr>
             </a:outerShdw>
           </a:effectLst>
         </p:spPr>
+        <p:txBody>
+          <a:bodyPr/>
+          <a:lstStyle/>
+          <a:p>
+            <a:endParaRPr lang="en-US"/>
+          </a:p>
+        </p:txBody>
       </p:sp>
       <p:sp>
         <p:nvSpPr>
@@ -5112,6 +5097,13 @@
             <a:prstDash val="solid"/>
           </a:ln>
         </p:spPr>
+        <p:txBody>
+          <a:bodyPr/>
+          <a:lstStyle/>
+          <a:p>
+            <a:endParaRPr lang="en-US"/>
+          </a:p>
+        </p:txBody>
       </p:sp>
       <p:sp>
         <p:nvSpPr>
@@ -5134,7 +5126,7 @@
           <a:bodyPr wrap="square" lIns="0" tIns="0" rIns="0" bIns="0" rtlCol="0" anchor="ctr"/>
           <a:lstStyle/>
           <a:p>
-            <a:pPr indent="0" marL="0">
+            <a:pPr marL="0" indent="0">
               <a:buNone/>
             </a:pPr>
             <a:r>
@@ -5170,7 +5162,7 @@
           <a:bodyPr wrap="square" lIns="0" tIns="0" rIns="0" bIns="0" rtlCol="0" anchor="ctr"/>
           <a:lstStyle/>
           <a:p>
-            <a:pPr indent="0" marL="0">
+            <a:pPr marL="0" indent="0">
               <a:buNone/>
             </a:pPr>
             <a:r>
@@ -5204,13 +5196,20 @@
           </a:solidFill>
           <a:ln/>
           <a:effectLst>
-            <a:outerShdw sx="100000" sy="100000" kx="0" ky="0" algn="bl" rotWithShape="0" blurRad="101600" dist="25400" dir="8100000">
+            <a:outerShdw blurRad="101600" dist="25400" dir="8100000" algn="bl" rotWithShape="0">
               <a:srgbClr val="000000">
                 <a:alpha val="10000"/>
               </a:srgbClr>
             </a:outerShdw>
           </a:effectLst>
         </p:spPr>
+        <p:txBody>
+          <a:bodyPr/>
+          <a:lstStyle/>
+          <a:p>
+            <a:endParaRPr lang="en-US"/>
+          </a:p>
+        </p:txBody>
       </p:sp>
       <p:sp>
         <p:nvSpPr>
@@ -5236,6 +5235,13 @@
             <a:prstDash val="solid"/>
           </a:ln>
         </p:spPr>
+        <p:txBody>
+          <a:bodyPr/>
+          <a:lstStyle/>
+          <a:p>
+            <a:endParaRPr lang="en-US"/>
+          </a:p>
+        </p:txBody>
       </p:sp>
       <p:sp>
         <p:nvSpPr>
@@ -5258,7 +5264,7 @@
           <a:bodyPr wrap="square" lIns="0" tIns="0" rIns="0" bIns="0" rtlCol="0" anchor="ctr"/>
           <a:lstStyle/>
           <a:p>
-            <a:pPr indent="0" marL="0">
+            <a:pPr marL="0" indent="0">
               <a:buNone/>
             </a:pPr>
             <a:r>
@@ -5294,7 +5300,7 @@
           <a:bodyPr wrap="square" lIns="0" tIns="0" rIns="0" bIns="0" rtlCol="0" anchor="ctr"/>
           <a:lstStyle/>
           <a:p>
-            <a:pPr indent="0" marL="0">
+            <a:pPr marL="0" indent="0">
               <a:buNone/>
             </a:pPr>
             <a:r>
@@ -5328,13 +5334,20 @@
           </a:solidFill>
           <a:ln/>
           <a:effectLst>
-            <a:outerShdw sx="100000" sy="100000" kx="0" ky="0" algn="bl" rotWithShape="0" blurRad="101600" dist="25400" dir="8100000">
+            <a:outerShdw blurRad="101600" dist="25400" dir="8100000" algn="bl" rotWithShape="0">
               <a:srgbClr val="000000">
                 <a:alpha val="10000"/>
               </a:srgbClr>
             </a:outerShdw>
           </a:effectLst>
         </p:spPr>
+        <p:txBody>
+          <a:bodyPr/>
+          <a:lstStyle/>
+          <a:p>
+            <a:endParaRPr lang="en-US"/>
+          </a:p>
+        </p:txBody>
       </p:sp>
       <p:sp>
         <p:nvSpPr>
@@ -5360,6 +5373,13 @@
             <a:prstDash val="solid"/>
           </a:ln>
         </p:spPr>
+        <p:txBody>
+          <a:bodyPr/>
+          <a:lstStyle/>
+          <a:p>
+            <a:endParaRPr lang="en-US"/>
+          </a:p>
+        </p:txBody>
       </p:sp>
       <p:sp>
         <p:nvSpPr>
@@ -5382,7 +5402,7 @@
           <a:bodyPr wrap="square" lIns="0" tIns="0" rIns="0" bIns="0" rtlCol="0" anchor="ctr"/>
           <a:lstStyle/>
           <a:p>
-            <a:pPr indent="0" marL="0">
+            <a:pPr marL="0" indent="0">
               <a:buNone/>
             </a:pPr>
             <a:r>
@@ -5418,7 +5438,7 @@
           <a:bodyPr wrap="square" lIns="0" tIns="0" rIns="0" bIns="0" rtlCol="0" anchor="ctr"/>
           <a:lstStyle/>
           <a:p>
-            <a:pPr indent="0" marL="0">
+            <a:pPr marL="0" indent="0">
               <a:buNone/>
             </a:pPr>
             <a:r>
@@ -5452,13 +5472,20 @@
           </a:solidFill>
           <a:ln/>
           <a:effectLst>
-            <a:outerShdw sx="100000" sy="100000" kx="0" ky="0" algn="bl" rotWithShape="0" blurRad="101600" dist="25400" dir="8100000">
+            <a:outerShdw blurRad="101600" dist="25400" dir="8100000" algn="bl" rotWithShape="0">
               <a:srgbClr val="000000">
                 <a:alpha val="10000"/>
               </a:srgbClr>
             </a:outerShdw>
           </a:effectLst>
         </p:spPr>
+        <p:txBody>
+          <a:bodyPr/>
+          <a:lstStyle/>
+          <a:p>
+            <a:endParaRPr lang="en-US"/>
+          </a:p>
+        </p:txBody>
       </p:sp>
       <p:sp>
         <p:nvSpPr>
@@ -5484,6 +5511,13 @@
             <a:prstDash val="solid"/>
           </a:ln>
         </p:spPr>
+        <p:txBody>
+          <a:bodyPr/>
+          <a:lstStyle/>
+          <a:p>
+            <a:endParaRPr lang="en-US"/>
+          </a:p>
+        </p:txBody>
       </p:sp>
       <p:sp>
         <p:nvSpPr>
@@ -5506,7 +5540,7 @@
           <a:bodyPr wrap="square" lIns="0" tIns="0" rIns="0" bIns="0" rtlCol="0" anchor="ctr"/>
           <a:lstStyle/>
           <a:p>
-            <a:pPr indent="0" marL="0">
+            <a:pPr marL="0" indent="0">
               <a:buNone/>
             </a:pPr>
             <a:r>
@@ -5542,7 +5576,7 @@
           <a:bodyPr wrap="square" lIns="0" tIns="0" rIns="0" bIns="0" rtlCol="0" anchor="ctr"/>
           <a:lstStyle/>
           <a:p>
-            <a:pPr indent="0" marL="0">
+            <a:pPr marL="0" indent="0">
               <a:buNone/>
             </a:pPr>
             <a:r>
@@ -5573,6 +5607,7 @@
         <a:solidFill>
           <a:srgbClr val="F8F9FC"/>
         </a:solidFill>
+        <a:effectLst/>
       </p:bgPr>
     </p:bg>
     <p:spTree>
@@ -5613,6 +5648,13 @@
             <a:prstDash val="solid"/>
           </a:ln>
         </p:spPr>
+        <p:txBody>
+          <a:bodyPr/>
+          <a:lstStyle/>
+          <a:p>
+            <a:endParaRPr lang="en-US"/>
+          </a:p>
+        </p:txBody>
       </p:sp>
       <p:sp>
         <p:nvSpPr>
@@ -5635,7 +5677,7 @@
           <a:bodyPr wrap="square" lIns="0" tIns="0" rIns="0" bIns="0" rtlCol="0" anchor="ctr"/>
           <a:lstStyle/>
           <a:p>
-            <a:pPr algn="l" indent="0" marL="0">
+            <a:pPr marL="0" indent="0" algn="l">
               <a:buNone/>
             </a:pPr>
             <a:r>
@@ -5671,7 +5713,7 @@
           <a:bodyPr wrap="square" lIns="0" tIns="0" rIns="0" bIns="0" rtlCol="0" anchor="ctr"/>
           <a:lstStyle/>
           <a:p>
-            <a:pPr indent="0" marL="0">
+            <a:pPr marL="0" indent="0">
               <a:buNone/>
             </a:pPr>
             <a:r>
@@ -5707,7 +5749,7 @@
           <a:bodyPr wrap="square" lIns="0" tIns="0" rIns="0" bIns="0" rtlCol="0" anchor="ctr"/>
           <a:lstStyle/>
           <a:p>
-            <a:pPr indent="0" marL="0">
+            <a:pPr marL="0" indent="0">
               <a:buNone/>
             </a:pPr>
             <a:r>
@@ -5746,6 +5788,13 @@
             <a:prstDash val="solid"/>
           </a:ln>
         </p:spPr>
+        <p:txBody>
+          <a:bodyPr/>
+          <a:lstStyle/>
+          <a:p>
+            <a:endParaRPr lang="en-US"/>
+          </a:p>
+        </p:txBody>
       </p:sp>
       <p:sp>
         <p:nvSpPr>
@@ -5768,7 +5817,7 @@
           <a:bodyPr wrap="square" lIns="0" tIns="0" rIns="0" bIns="0" rtlCol="0" anchor="ctr"/>
           <a:lstStyle/>
           <a:p>
-            <a:pPr indent="0" marL="0">
+            <a:pPr marL="0" indent="0">
               <a:buNone/>
             </a:pPr>
             <a:r>
@@ -5804,7 +5853,7 @@
           <a:bodyPr wrap="square" lIns="0" tIns="0" rIns="0" bIns="0" rtlCol="0" anchor="ctr"/>
           <a:lstStyle/>
           <a:p>
-            <a:pPr indent="0" marL="0">
+            <a:pPr marL="0" indent="0">
               <a:buNone/>
             </a:pPr>
             <a:r>
@@ -5843,6 +5892,13 @@
             <a:prstDash val="solid"/>
           </a:ln>
         </p:spPr>
+        <p:txBody>
+          <a:bodyPr/>
+          <a:lstStyle/>
+          <a:p>
+            <a:endParaRPr lang="en-US"/>
+          </a:p>
+        </p:txBody>
       </p:sp>
       <p:sp>
         <p:nvSpPr>
@@ -5865,7 +5921,7 @@
           <a:bodyPr wrap="square" lIns="0" tIns="0" rIns="0" bIns="0" rtlCol="0" anchor="ctr"/>
           <a:lstStyle/>
           <a:p>
-            <a:pPr indent="0" marL="0">
+            <a:pPr marL="0" indent="0">
               <a:buNone/>
             </a:pPr>
             <a:r>
@@ -5901,7 +5957,7 @@
           <a:bodyPr wrap="square" lIns="0" tIns="0" rIns="0" bIns="0" rtlCol="0" anchor="ctr"/>
           <a:lstStyle/>
           <a:p>
-            <a:pPr indent="0" marL="0">
+            <a:pPr marL="0" indent="0">
               <a:buNone/>
             </a:pPr>
             <a:r>
@@ -5940,6 +5996,13 @@
             <a:prstDash val="solid"/>
           </a:ln>
         </p:spPr>
+        <p:txBody>
+          <a:bodyPr/>
+          <a:lstStyle/>
+          <a:p>
+            <a:endParaRPr lang="en-US"/>
+          </a:p>
+        </p:txBody>
       </p:sp>
       <p:sp>
         <p:nvSpPr>
@@ -5962,7 +6025,7 @@
           <a:bodyPr wrap="square" lIns="0" tIns="0" rIns="0" bIns="0" rtlCol="0" anchor="ctr"/>
           <a:lstStyle/>
           <a:p>
-            <a:pPr indent="0" marL="0">
+            <a:pPr marL="0" indent="0">
               <a:buNone/>
             </a:pPr>
             <a:r>
@@ -5998,7 +6061,7 @@
           <a:bodyPr wrap="square" lIns="0" tIns="0" rIns="0" bIns="0" rtlCol="0" anchor="ctr"/>
           <a:lstStyle/>
           <a:p>
-            <a:pPr indent="0" marL="0">
+            <a:pPr marL="0" indent="0">
               <a:buNone/>
             </a:pPr>
             <a:r>
@@ -6037,6 +6100,13 @@
             <a:prstDash val="solid"/>
           </a:ln>
         </p:spPr>
+        <p:txBody>
+          <a:bodyPr/>
+          <a:lstStyle/>
+          <a:p>
+            <a:endParaRPr lang="en-US"/>
+          </a:p>
+        </p:txBody>
       </p:sp>
       <p:sp>
         <p:nvSpPr>
@@ -6059,7 +6129,7 @@
           <a:bodyPr wrap="square" lIns="0" tIns="0" rIns="0" bIns="0" rtlCol="0" anchor="ctr"/>
           <a:lstStyle/>
           <a:p>
-            <a:pPr indent="0" marL="0">
+            <a:pPr marL="0" indent="0">
               <a:buNone/>
             </a:pPr>
             <a:r>
@@ -6095,7 +6165,7 @@
           <a:bodyPr wrap="square" lIns="0" tIns="0" rIns="0" bIns="0" rtlCol="0" anchor="ctr"/>
           <a:lstStyle/>
           <a:p>
-            <a:pPr indent="0" marL="0">
+            <a:pPr marL="0" indent="0">
               <a:buNone/>
             </a:pPr>
             <a:r>
@@ -6134,6 +6204,13 @@
             <a:prstDash val="solid"/>
           </a:ln>
         </p:spPr>
+        <p:txBody>
+          <a:bodyPr/>
+          <a:lstStyle/>
+          <a:p>
+            <a:endParaRPr lang="en-US"/>
+          </a:p>
+        </p:txBody>
       </p:sp>
       <p:sp>
         <p:nvSpPr>
@@ -6156,7 +6233,7 @@
           <a:bodyPr wrap="square" lIns="0" tIns="0" rIns="0" bIns="0" rtlCol="0" anchor="ctr"/>
           <a:lstStyle/>
           <a:p>
-            <a:pPr indent="0" marL="0">
+            <a:pPr marL="0" indent="0">
               <a:buNone/>
             </a:pPr>
             <a:r>
@@ -6195,6 +6272,13 @@
             <a:prstDash val="solid"/>
           </a:ln>
         </p:spPr>
+        <p:txBody>
+          <a:bodyPr/>
+          <a:lstStyle/>
+          <a:p>
+            <a:endParaRPr lang="en-US"/>
+          </a:p>
+        </p:txBody>
       </p:sp>
       <p:sp>
         <p:nvSpPr>
@@ -6217,7 +6301,7 @@
           <a:bodyPr wrap="square" lIns="0" tIns="0" rIns="0" bIns="0" rtlCol="0" anchor="ctr"/>
           <a:lstStyle/>
           <a:p>
-            <a:pPr indent="0" marL="0">
+            <a:pPr marL="0" indent="0">
               <a:buNone/>
             </a:pPr>
             <a:r>
@@ -6254,6 +6338,13 @@
             <a:prstDash val="solid"/>
           </a:ln>
         </p:spPr>
+        <p:txBody>
+          <a:bodyPr/>
+          <a:lstStyle/>
+          <a:p>
+            <a:endParaRPr lang="en-US"/>
+          </a:p>
+        </p:txBody>
       </p:sp>
       <p:sp>
         <p:nvSpPr>
@@ -6276,7 +6367,7 @@
           <a:bodyPr wrap="square" lIns="0" tIns="0" rIns="0" bIns="0" rtlCol="0" anchor="ctr"/>
           <a:lstStyle/>
           <a:p>
-            <a:pPr indent="0" marL="0">
+            <a:pPr marL="0" indent="0">
               <a:buNone/>
             </a:pPr>
             <a:r>
@@ -6312,7 +6403,7 @@
           <a:bodyPr wrap="square" lIns="0" tIns="0" rIns="0" bIns="0" rtlCol="0" anchor="ctr"/>
           <a:lstStyle/>
           <a:p>
-            <a:pPr indent="0" marL="0">
+            <a:pPr marL="0" indent="0">
               <a:lnSpc>
                 <a:spcPct val="130000"/>
               </a:lnSpc>
@@ -6351,7 +6442,7 @@
           <a:bodyPr wrap="square" lIns="0" tIns="0" rIns="0" bIns="0" rtlCol="0" anchor="ctr"/>
           <a:lstStyle/>
           <a:p>
-            <a:pPr indent="0" marL="0">
+            <a:pPr marL="0" indent="0">
               <a:buNone/>
             </a:pPr>
             <a:r>
@@ -6387,7 +6478,7 @@
           <a:bodyPr wrap="square" lIns="0" tIns="0" rIns="0" bIns="0" rtlCol="0" anchor="ctr"/>
           <a:lstStyle/>
           <a:p>
-            <a:pPr indent="0" marL="0">
+            <a:pPr marL="0" indent="0">
               <a:lnSpc>
                 <a:spcPct val="130000"/>
               </a:lnSpc>
@@ -6404,7 +6495,7 @@
             <a:endParaRPr lang="en-US" sz="950" dirty="0"/>
           </a:p>
           <a:p>
-            <a:pPr indent="0" marL="0">
+            <a:pPr marL="0" indent="0">
               <a:lnSpc>
                 <a:spcPct val="130000"/>
               </a:lnSpc>
@@ -6413,7 +6504,7 @@
             <a:endParaRPr lang="en-US" sz="950" dirty="0"/>
           </a:p>
           <a:p>
-            <a:pPr indent="0" marL="0">
+            <a:pPr marL="0" indent="0">
               <a:lnSpc>
                 <a:spcPct val="130000"/>
               </a:lnSpc>
@@ -6447,6 +6538,7 @@
         <a:solidFill>
           <a:srgbClr val="F8F9FC"/>
         </a:solidFill>
+        <a:effectLst/>
       </p:bgPr>
     </p:bg>
     <p:spTree>
@@ -6487,6 +6579,13 @@
             <a:prstDash val="solid"/>
           </a:ln>
         </p:spPr>
+        <p:txBody>
+          <a:bodyPr/>
+          <a:lstStyle/>
+          <a:p>
+            <a:endParaRPr lang="en-US"/>
+          </a:p>
+        </p:txBody>
       </p:sp>
       <p:sp>
         <p:nvSpPr>
@@ -6509,7 +6608,7 @@
           <a:bodyPr wrap="square" lIns="0" tIns="0" rIns="0" bIns="0" rtlCol="0" anchor="ctr"/>
           <a:lstStyle/>
           <a:p>
-            <a:pPr algn="l" indent="0" marL="0">
+            <a:pPr marL="0" indent="0" algn="l">
               <a:buNone/>
             </a:pPr>
             <a:r>
@@ -6545,7 +6644,7 @@
           <a:bodyPr wrap="square" lIns="0" tIns="0" rIns="0" bIns="0" rtlCol="0" anchor="ctr"/>
           <a:lstStyle/>
           <a:p>
-            <a:pPr indent="0" marL="0">
+            <a:pPr marL="0" indent="0">
               <a:buNone/>
             </a:pPr>
             <a:r>
@@ -6584,6 +6683,13 @@
             <a:prstDash val="solid"/>
           </a:ln>
         </p:spPr>
+        <p:txBody>
+          <a:bodyPr/>
+          <a:lstStyle/>
+          <a:p>
+            <a:endParaRPr lang="en-US"/>
+          </a:p>
+        </p:txBody>
       </p:sp>
       <p:sp>
         <p:nvSpPr>
@@ -6606,7 +6712,7 @@
           <a:bodyPr wrap="square" lIns="0" tIns="0" rIns="0" bIns="0" rtlCol="0" anchor="ctr"/>
           <a:lstStyle/>
           <a:p>
-            <a:pPr algn="ctr" indent="0" marL="0">
+            <a:pPr marL="0" indent="0" algn="ctr">
               <a:buNone/>
             </a:pPr>
             <a:r>
@@ -6642,7 +6748,7 @@
           <a:bodyPr wrap="square" lIns="0" tIns="0" rIns="0" bIns="0" rtlCol="0" anchor="ctr"/>
           <a:lstStyle/>
           <a:p>
-            <a:pPr indent="0" marL="0">
+            <a:pPr marL="0" indent="0">
               <a:buNone/>
             </a:pPr>
             <a:r>
@@ -6681,6 +6787,13 @@
             <a:prstDash val="solid"/>
           </a:ln>
         </p:spPr>
+        <p:txBody>
+          <a:bodyPr/>
+          <a:lstStyle/>
+          <a:p>
+            <a:endParaRPr lang="en-US"/>
+          </a:p>
+        </p:txBody>
       </p:sp>
       <p:sp>
         <p:nvSpPr>
@@ -6703,7 +6816,7 @@
           <a:bodyPr wrap="square" lIns="0" tIns="0" rIns="0" bIns="0" rtlCol="0" anchor="ctr"/>
           <a:lstStyle/>
           <a:p>
-            <a:pPr algn="ctr" indent="0" marL="0">
+            <a:pPr marL="0" indent="0" algn="ctr">
               <a:buNone/>
             </a:pPr>
             <a:r>
@@ -6739,7 +6852,7 @@
           <a:bodyPr wrap="square" lIns="0" tIns="0" rIns="0" bIns="0" rtlCol="0" anchor="ctr"/>
           <a:lstStyle/>
           <a:p>
-            <a:pPr indent="0" marL="0">
+            <a:pPr marL="0" indent="0">
               <a:buNone/>
             </a:pPr>
             <a:r>
@@ -6778,6 +6891,13 @@
             <a:prstDash val="solid"/>
           </a:ln>
         </p:spPr>
+        <p:txBody>
+          <a:bodyPr/>
+          <a:lstStyle/>
+          <a:p>
+            <a:endParaRPr lang="en-US"/>
+          </a:p>
+        </p:txBody>
       </p:sp>
       <p:sp>
         <p:nvSpPr>
@@ -6800,7 +6920,7 @@
           <a:bodyPr wrap="square" lIns="0" tIns="0" rIns="0" bIns="0" rtlCol="0" anchor="ctr"/>
           <a:lstStyle/>
           <a:p>
-            <a:pPr algn="ctr" indent="0" marL="0">
+            <a:pPr marL="0" indent="0" algn="ctr">
               <a:buNone/>
             </a:pPr>
             <a:r>
@@ -6836,7 +6956,7 @@
           <a:bodyPr wrap="square" lIns="0" tIns="0" rIns="0" bIns="0" rtlCol="0" anchor="ctr"/>
           <a:lstStyle/>
           <a:p>
-            <a:pPr indent="0" marL="0">
+            <a:pPr marL="0" indent="0">
               <a:buNone/>
             </a:pPr>
             <a:r>
@@ -6875,6 +6995,13 @@
             <a:prstDash val="solid"/>
           </a:ln>
         </p:spPr>
+        <p:txBody>
+          <a:bodyPr/>
+          <a:lstStyle/>
+          <a:p>
+            <a:endParaRPr lang="en-US"/>
+          </a:p>
+        </p:txBody>
       </p:sp>
       <p:sp>
         <p:nvSpPr>
@@ -6897,7 +7024,7 @@
           <a:bodyPr wrap="square" lIns="0" tIns="0" rIns="0" bIns="0" rtlCol="0" anchor="ctr"/>
           <a:lstStyle/>
           <a:p>
-            <a:pPr algn="ctr" indent="0" marL="0">
+            <a:pPr marL="0" indent="0" algn="ctr">
               <a:buNone/>
             </a:pPr>
             <a:r>
@@ -6933,7 +7060,7 @@
           <a:bodyPr wrap="square" lIns="0" tIns="0" rIns="0" bIns="0" rtlCol="0" anchor="ctr"/>
           <a:lstStyle/>
           <a:p>
-            <a:pPr indent="0" marL="0">
+            <a:pPr marL="0" indent="0">
               <a:buNone/>
             </a:pPr>
             <a:r>
@@ -6972,6 +7099,13 @@
             <a:prstDash val="solid"/>
           </a:ln>
         </p:spPr>
+        <p:txBody>
+          <a:bodyPr/>
+          <a:lstStyle/>
+          <a:p>
+            <a:endParaRPr lang="en-US"/>
+          </a:p>
+        </p:txBody>
       </p:sp>
       <p:sp>
         <p:nvSpPr>
@@ -6994,7 +7128,7 @@
           <a:bodyPr wrap="square" lIns="0" tIns="0" rIns="0" bIns="0" rtlCol="0" anchor="ctr"/>
           <a:lstStyle/>
           <a:p>
-            <a:pPr algn="ctr" indent="0" marL="0">
+            <a:pPr marL="0" indent="0" algn="ctr">
               <a:buNone/>
             </a:pPr>
             <a:r>
@@ -7030,7 +7164,7 @@
           <a:bodyPr wrap="square" lIns="0" tIns="0" rIns="0" bIns="0" rtlCol="0" anchor="ctr"/>
           <a:lstStyle/>
           <a:p>
-            <a:pPr indent="0" marL="0">
+            <a:pPr marL="0" indent="0">
               <a:buNone/>
             </a:pPr>
             <a:r>
@@ -7069,6 +7203,13 @@
             <a:prstDash val="solid"/>
           </a:ln>
         </p:spPr>
+        <p:txBody>
+          <a:bodyPr/>
+          <a:lstStyle/>
+          <a:p>
+            <a:endParaRPr lang="en-US"/>
+          </a:p>
+        </p:txBody>
       </p:sp>
       <p:sp>
         <p:nvSpPr>
@@ -7091,7 +7232,7 @@
           <a:bodyPr wrap="square" lIns="0" tIns="0" rIns="0" bIns="0" rtlCol="0" anchor="ctr"/>
           <a:lstStyle/>
           <a:p>
-            <a:pPr indent="0" marL="0">
+            <a:pPr marL="0" indent="0">
               <a:buNone/>
             </a:pPr>
             <a:r>
@@ -7128,6 +7269,13 @@
             <a:prstDash val="solid"/>
           </a:ln>
         </p:spPr>
+        <p:txBody>
+          <a:bodyPr/>
+          <a:lstStyle/>
+          <a:p>
+            <a:endParaRPr lang="en-US"/>
+          </a:p>
+        </p:txBody>
       </p:sp>
       <p:sp>
         <p:nvSpPr>
@@ -7150,7 +7298,7 @@
           <a:bodyPr wrap="square" lIns="0" tIns="0" rIns="0" bIns="0" rtlCol="0" anchor="ctr"/>
           <a:lstStyle/>
           <a:p>
-            <a:pPr indent="0" marL="0">
+            <a:pPr marL="0" indent="0">
               <a:buNone/>
             </a:pPr>
             <a:r>
@@ -7186,7 +7334,7 @@
           <a:bodyPr wrap="square" lIns="0" tIns="0" rIns="0" bIns="0" rtlCol="0" anchor="ctr"/>
           <a:lstStyle/>
           <a:p>
-            <a:pPr indent="0" marL="0">
+            <a:pPr marL="0" indent="0">
               <a:buNone/>
             </a:pPr>
             <a:r>
@@ -7225,6 +7373,13 @@
             <a:prstDash val="solid"/>
           </a:ln>
         </p:spPr>
+        <p:txBody>
+          <a:bodyPr/>
+          <a:lstStyle/>
+          <a:p>
+            <a:endParaRPr lang="en-US"/>
+          </a:p>
+        </p:txBody>
       </p:sp>
       <p:sp>
         <p:nvSpPr>
@@ -7247,7 +7402,7 @@
           <a:bodyPr wrap="square" lIns="0" tIns="0" rIns="0" bIns="0" rtlCol="0" anchor="ctr"/>
           <a:lstStyle/>
           <a:p>
-            <a:pPr indent="0" marL="0">
+            <a:pPr marL="0" indent="0">
               <a:buNone/>
             </a:pPr>
             <a:r>
@@ -7283,7 +7438,7 @@
           <a:bodyPr wrap="square" lIns="0" tIns="0" rIns="0" bIns="0" rtlCol="0" anchor="ctr"/>
           <a:lstStyle/>
           <a:p>
-            <a:pPr indent="0" marL="0">
+            <a:pPr marL="0" indent="0">
               <a:buNone/>
             </a:pPr>
             <a:r>
@@ -7322,6 +7477,13 @@
             <a:prstDash val="solid"/>
           </a:ln>
         </p:spPr>
+        <p:txBody>
+          <a:bodyPr/>
+          <a:lstStyle/>
+          <a:p>
+            <a:endParaRPr lang="en-US"/>
+          </a:p>
+        </p:txBody>
       </p:sp>
       <p:sp>
         <p:nvSpPr>
@@ -7344,7 +7506,7 @@
           <a:bodyPr wrap="square" lIns="0" tIns="0" rIns="0" bIns="0" rtlCol="0" anchor="ctr"/>
           <a:lstStyle/>
           <a:p>
-            <a:pPr indent="0" marL="0">
+            <a:pPr marL="0" indent="0">
               <a:buNone/>
             </a:pPr>
             <a:r>
@@ -7380,7 +7542,7 @@
           <a:bodyPr wrap="square" lIns="0" tIns="0" rIns="0" bIns="0" rtlCol="0" anchor="ctr"/>
           <a:lstStyle/>
           <a:p>
-            <a:pPr indent="0" marL="0">
+            <a:pPr marL="0" indent="0">
               <a:buNone/>
             </a:pPr>
             <a:r>
@@ -7419,6 +7581,13 @@
             <a:prstDash val="solid"/>
           </a:ln>
         </p:spPr>
+        <p:txBody>
+          <a:bodyPr/>
+          <a:lstStyle/>
+          <a:p>
+            <a:endParaRPr lang="en-US"/>
+          </a:p>
+        </p:txBody>
       </p:sp>
       <p:sp>
         <p:nvSpPr>
@@ -7441,7 +7610,7 @@
           <a:bodyPr wrap="square" lIns="0" tIns="0" rIns="0" bIns="0" rtlCol="0" anchor="ctr"/>
           <a:lstStyle/>
           <a:p>
-            <a:pPr indent="0" marL="0">
+            <a:pPr marL="0" indent="0">
               <a:buNone/>
             </a:pPr>
             <a:r>
@@ -7477,7 +7646,7 @@
           <a:bodyPr wrap="square" lIns="0" tIns="0" rIns="0" bIns="0" rtlCol="0" anchor="ctr"/>
           <a:lstStyle/>
           <a:p>
-            <a:pPr indent="0" marL="0">
+            <a:pPr marL="0" indent="0">
               <a:buNone/>
             </a:pPr>
             <a:r>
@@ -7516,6 +7685,13 @@
             <a:prstDash val="solid"/>
           </a:ln>
         </p:spPr>
+        <p:txBody>
+          <a:bodyPr/>
+          <a:lstStyle/>
+          <a:p>
+            <a:endParaRPr lang="en-US"/>
+          </a:p>
+        </p:txBody>
       </p:sp>
       <p:sp>
         <p:nvSpPr>
@@ -7538,7 +7714,7 @@
           <a:bodyPr wrap="square" lIns="0" tIns="0" rIns="0" bIns="0" rtlCol="0" anchor="ctr"/>
           <a:lstStyle/>
           <a:p>
-            <a:pPr indent="0" marL="0">
+            <a:pPr marL="0" indent="0">
               <a:buNone/>
             </a:pPr>
             <a:r>
@@ -7574,7 +7750,7 @@
           <a:bodyPr wrap="square" lIns="0" tIns="0" rIns="0" bIns="0" rtlCol="0" anchor="ctr"/>
           <a:lstStyle/>
           <a:p>
-            <a:pPr indent="0" marL="0">
+            <a:pPr marL="0" indent="0">
               <a:buNone/>
             </a:pPr>
             <a:r>
@@ -7613,6 +7789,13 @@
             <a:prstDash val="solid"/>
           </a:ln>
         </p:spPr>
+        <p:txBody>
+          <a:bodyPr/>
+          <a:lstStyle/>
+          <a:p>
+            <a:endParaRPr lang="en-US"/>
+          </a:p>
+        </p:txBody>
       </p:sp>
       <p:sp>
         <p:nvSpPr>
@@ -7635,7 +7818,7 @@
           <a:bodyPr wrap="square" lIns="0" tIns="0" rIns="0" bIns="0" rtlCol="0" anchor="ctr"/>
           <a:lstStyle/>
           <a:p>
-            <a:pPr indent="0" marL="0">
+            <a:pPr marL="0" indent="0">
               <a:buNone/>
             </a:pPr>
             <a:r>
@@ -7671,7 +7854,7 @@
           <a:bodyPr wrap="square" lIns="0" tIns="0" rIns="0" bIns="0" rtlCol="0" anchor="ctr"/>
           <a:lstStyle/>
           <a:p>
-            <a:pPr indent="0" marL="0">
+            <a:pPr marL="0" indent="0">
               <a:buNone/>
             </a:pPr>
             <a:r>
@@ -7710,6 +7893,13 @@
             <a:prstDash val="solid"/>
           </a:ln>
         </p:spPr>
+        <p:txBody>
+          <a:bodyPr/>
+          <a:lstStyle/>
+          <a:p>
+            <a:endParaRPr lang="en-US"/>
+          </a:p>
+        </p:txBody>
       </p:sp>
       <p:sp>
         <p:nvSpPr>
@@ -7732,7 +7922,7 @@
           <a:bodyPr wrap="square" lIns="0" tIns="0" rIns="0" bIns="0" rtlCol="0" anchor="ctr"/>
           <a:lstStyle/>
           <a:p>
-            <a:pPr indent="0" marL="0">
+            <a:pPr marL="0" indent="0">
               <a:buNone/>
             </a:pPr>
             <a:r>
@@ -7763,6 +7953,7 @@
         <a:solidFill>
           <a:srgbClr val="F8F9FC"/>
         </a:solidFill>
+        <a:effectLst/>
       </p:bgPr>
     </p:bg>
     <p:spTree>
@@ -7803,6 +7994,13 @@
             <a:prstDash val="solid"/>
           </a:ln>
         </p:spPr>
+        <p:txBody>
+          <a:bodyPr/>
+          <a:lstStyle/>
+          <a:p>
+            <a:endParaRPr lang="en-US"/>
+          </a:p>
+        </p:txBody>
       </p:sp>
       <p:sp>
         <p:nvSpPr>
@@ -7825,7 +8023,7 @@
           <a:bodyPr wrap="square" lIns="0" tIns="0" rIns="0" bIns="0" rtlCol="0" anchor="ctr"/>
           <a:lstStyle/>
           <a:p>
-            <a:pPr algn="l" indent="0" marL="0">
+            <a:pPr marL="0" indent="0" algn="l">
               <a:buNone/>
             </a:pPr>
             <a:r>
@@ -7861,7 +8059,7 @@
           <a:bodyPr wrap="square" lIns="0" tIns="0" rIns="0" bIns="0" rtlCol="0" anchor="ctr"/>
           <a:lstStyle/>
           <a:p>
-            <a:pPr indent="0" marL="0">
+            <a:pPr marL="0" indent="0">
               <a:buNone/>
             </a:pPr>
             <a:r>
@@ -7895,13 +8093,20 @@
           </a:solidFill>
           <a:ln/>
           <a:effectLst>
-            <a:outerShdw sx="100000" sy="100000" kx="0" ky="0" algn="bl" rotWithShape="0" blurRad="101600" dist="25400" dir="8100000">
+            <a:outerShdw blurRad="101600" dist="25400" dir="8100000" algn="bl" rotWithShape="0">
               <a:srgbClr val="000000">
                 <a:alpha val="10000"/>
               </a:srgbClr>
             </a:outerShdw>
           </a:effectLst>
         </p:spPr>
+        <p:txBody>
+          <a:bodyPr/>
+          <a:lstStyle/>
+          <a:p>
+            <a:endParaRPr lang="en-US"/>
+          </a:p>
+        </p:txBody>
       </p:sp>
       <p:sp>
         <p:nvSpPr>
@@ -7927,6 +8132,13 @@
             <a:prstDash val="solid"/>
           </a:ln>
         </p:spPr>
+        <p:txBody>
+          <a:bodyPr/>
+          <a:lstStyle/>
+          <a:p>
+            <a:endParaRPr lang="en-US"/>
+          </a:p>
+        </p:txBody>
       </p:sp>
       <p:sp>
         <p:nvSpPr>
@@ -7949,7 +8161,7 @@
           <a:bodyPr wrap="square" lIns="0" tIns="0" rIns="0" bIns="0" rtlCol="0" anchor="ctr"/>
           <a:lstStyle/>
           <a:p>
-            <a:pPr algn="ctr" indent="0" marL="0">
+            <a:pPr marL="0" indent="0" algn="ctr">
               <a:buNone/>
             </a:pPr>
             <a:r>
@@ -7985,7 +8197,7 @@
           <a:bodyPr wrap="square" lIns="0" tIns="0" rIns="0" bIns="0" rtlCol="0" anchor="ctr"/>
           <a:lstStyle/>
           <a:p>
-            <a:pPr indent="0" marL="0">
+            <a:pPr marL="0" indent="0">
               <a:lnSpc>
                 <a:spcPct val="135000"/>
               </a:lnSpc>
@@ -8002,7 +8214,7 @@
             <a:endParaRPr lang="en-US" sz="950" dirty="0"/>
           </a:p>
           <a:p>
-            <a:pPr indent="0" marL="0">
+            <a:pPr marL="0" indent="0">
               <a:lnSpc>
                 <a:spcPct val="135000"/>
               </a:lnSpc>
@@ -8019,7 +8231,7 @@
             <a:endParaRPr lang="en-US" sz="950" dirty="0"/>
           </a:p>
           <a:p>
-            <a:pPr indent="0" marL="0">
+            <a:pPr marL="0" indent="0">
               <a:lnSpc>
                 <a:spcPct val="135000"/>
               </a:lnSpc>
@@ -8028,7 +8240,7 @@
             <a:endParaRPr lang="en-US" sz="950" dirty="0"/>
           </a:p>
           <a:p>
-            <a:pPr indent="0" marL="0">
+            <a:pPr marL="0" indent="0">
               <a:lnSpc>
                 <a:spcPct val="135000"/>
               </a:lnSpc>
@@ -8045,7 +8257,7 @@
             <a:endParaRPr lang="en-US" sz="950" dirty="0"/>
           </a:p>
           <a:p>
-            <a:pPr indent="0" marL="0">
+            <a:pPr marL="0" indent="0">
               <a:lnSpc>
                 <a:spcPct val="135000"/>
               </a:lnSpc>
@@ -8062,7 +8274,7 @@
             <a:endParaRPr lang="en-US" sz="950" dirty="0"/>
           </a:p>
           <a:p>
-            <a:pPr indent="0" marL="0">
+            <a:pPr marL="0" indent="0">
               <a:lnSpc>
                 <a:spcPct val="135000"/>
               </a:lnSpc>
@@ -8079,7 +8291,7 @@
             <a:endParaRPr lang="en-US" sz="950" dirty="0"/>
           </a:p>
           <a:p>
-            <a:pPr indent="0" marL="0">
+            <a:pPr marL="0" indent="0">
               <a:lnSpc>
                 <a:spcPct val="135000"/>
               </a:lnSpc>
@@ -8116,13 +8328,20 @@
           </a:solidFill>
           <a:ln/>
           <a:effectLst>
-            <a:outerShdw sx="100000" sy="100000" kx="0" ky="0" algn="bl" rotWithShape="0" blurRad="101600" dist="25400" dir="8100000">
+            <a:outerShdw blurRad="101600" dist="25400" dir="8100000" algn="bl" rotWithShape="0">
               <a:srgbClr val="000000">
                 <a:alpha val="10000"/>
               </a:srgbClr>
             </a:outerShdw>
           </a:effectLst>
         </p:spPr>
+        <p:txBody>
+          <a:bodyPr/>
+          <a:lstStyle/>
+          <a:p>
+            <a:endParaRPr lang="en-US"/>
+          </a:p>
+        </p:txBody>
       </p:sp>
       <p:sp>
         <p:nvSpPr>
@@ -8148,6 +8367,13 @@
             <a:prstDash val="solid"/>
           </a:ln>
         </p:spPr>
+        <p:txBody>
+          <a:bodyPr/>
+          <a:lstStyle/>
+          <a:p>
+            <a:endParaRPr lang="en-US"/>
+          </a:p>
+        </p:txBody>
       </p:sp>
       <p:sp>
         <p:nvSpPr>
@@ -8170,7 +8396,7 @@
           <a:bodyPr wrap="square" lIns="0" tIns="0" rIns="0" bIns="0" rtlCol="0" anchor="ctr"/>
           <a:lstStyle/>
           <a:p>
-            <a:pPr algn="ctr" indent="0" marL="0">
+            <a:pPr marL="0" indent="0" algn="ctr">
               <a:buNone/>
             </a:pPr>
             <a:r>
@@ -8206,7 +8432,7 @@
           <a:bodyPr wrap="square" lIns="0" tIns="0" rIns="0" bIns="0" rtlCol="0" anchor="ctr"/>
           <a:lstStyle/>
           <a:p>
-            <a:pPr indent="0" marL="0">
+            <a:pPr marL="0" indent="0">
               <a:lnSpc>
                 <a:spcPct val="135000"/>
               </a:lnSpc>
@@ -8223,7 +8449,7 @@
             <a:endParaRPr lang="en-US" sz="950" dirty="0"/>
           </a:p>
           <a:p>
-            <a:pPr indent="0" marL="0">
+            <a:pPr marL="0" indent="0">
               <a:lnSpc>
                 <a:spcPct val="135000"/>
               </a:lnSpc>
@@ -8240,7 +8466,7 @@
             <a:endParaRPr lang="en-US" sz="950" dirty="0"/>
           </a:p>
           <a:p>
-            <a:pPr indent="0" marL="0">
+            <a:pPr marL="0" indent="0">
               <a:lnSpc>
                 <a:spcPct val="135000"/>
               </a:lnSpc>
@@ -8249,7 +8475,7 @@
             <a:endParaRPr lang="en-US" sz="950" dirty="0"/>
           </a:p>
           <a:p>
-            <a:pPr indent="0" marL="0">
+            <a:pPr marL="0" indent="0">
               <a:lnSpc>
                 <a:spcPct val="135000"/>
               </a:lnSpc>
@@ -8266,7 +8492,7 @@
             <a:endParaRPr lang="en-US" sz="950" dirty="0"/>
           </a:p>
           <a:p>
-            <a:pPr indent="0" marL="0">
+            <a:pPr marL="0" indent="0">
               <a:lnSpc>
                 <a:spcPct val="135000"/>
               </a:lnSpc>
@@ -8283,7 +8509,7 @@
             <a:endParaRPr lang="en-US" sz="950" dirty="0"/>
           </a:p>
           <a:p>
-            <a:pPr indent="0" marL="0">
+            <a:pPr marL="0" indent="0">
               <a:lnSpc>
                 <a:spcPct val="135000"/>
               </a:lnSpc>
@@ -8300,7 +8526,7 @@
             <a:endParaRPr lang="en-US" sz="950" dirty="0"/>
           </a:p>
           <a:p>
-            <a:pPr indent="0" marL="0">
+            <a:pPr marL="0" indent="0">
               <a:lnSpc>
                 <a:spcPct val="135000"/>
               </a:lnSpc>
@@ -8337,13 +8563,20 @@
           </a:solidFill>
           <a:ln/>
           <a:effectLst>
-            <a:outerShdw sx="100000" sy="100000" kx="0" ky="0" algn="bl" rotWithShape="0" blurRad="101600" dist="25400" dir="8100000">
+            <a:outerShdw blurRad="101600" dist="25400" dir="8100000" algn="bl" rotWithShape="0">
               <a:srgbClr val="000000">
                 <a:alpha val="10000"/>
               </a:srgbClr>
             </a:outerShdw>
           </a:effectLst>
         </p:spPr>
+        <p:txBody>
+          <a:bodyPr/>
+          <a:lstStyle/>
+          <a:p>
+            <a:endParaRPr lang="en-US"/>
+          </a:p>
+        </p:txBody>
       </p:sp>
       <p:sp>
         <p:nvSpPr>
@@ -8369,6 +8602,13 @@
             <a:prstDash val="solid"/>
           </a:ln>
         </p:spPr>
+        <p:txBody>
+          <a:bodyPr/>
+          <a:lstStyle/>
+          <a:p>
+            <a:endParaRPr lang="en-US"/>
+          </a:p>
+        </p:txBody>
       </p:sp>
       <p:sp>
         <p:nvSpPr>
@@ -8391,7 +8631,7 @@
           <a:bodyPr wrap="square" lIns="0" tIns="0" rIns="0" bIns="0" rtlCol="0" anchor="ctr"/>
           <a:lstStyle/>
           <a:p>
-            <a:pPr algn="ctr" indent="0" marL="0">
+            <a:pPr marL="0" indent="0" algn="ctr">
               <a:buNone/>
             </a:pPr>
             <a:r>
@@ -8427,7 +8667,7 @@
           <a:bodyPr wrap="square" lIns="0" tIns="0" rIns="0" bIns="0" rtlCol="0" anchor="ctr"/>
           <a:lstStyle/>
           <a:p>
-            <a:pPr indent="0" marL="0">
+            <a:pPr marL="0" indent="0">
               <a:lnSpc>
                 <a:spcPct val="135000"/>
               </a:lnSpc>
@@ -8444,7 +8684,7 @@
             <a:endParaRPr lang="en-US" sz="950" dirty="0"/>
           </a:p>
           <a:p>
-            <a:pPr indent="0" marL="0">
+            <a:pPr marL="0" indent="0">
               <a:lnSpc>
                 <a:spcPct val="135000"/>
               </a:lnSpc>
@@ -8453,7 +8693,7 @@
             <a:endParaRPr lang="en-US" sz="950" dirty="0"/>
           </a:p>
           <a:p>
-            <a:pPr indent="0" marL="0">
+            <a:pPr marL="0" indent="0">
               <a:lnSpc>
                 <a:spcPct val="135000"/>
               </a:lnSpc>
@@ -8470,7 +8710,7 @@
             <a:endParaRPr lang="en-US" sz="950" dirty="0"/>
           </a:p>
           <a:p>
-            <a:pPr indent="0" marL="0">
+            <a:pPr marL="0" indent="0">
               <a:lnSpc>
                 <a:spcPct val="135000"/>
               </a:lnSpc>
@@ -8487,7 +8727,7 @@
             <a:endParaRPr lang="en-US" sz="950" dirty="0"/>
           </a:p>
           <a:p>
-            <a:pPr indent="0" marL="0">
+            <a:pPr marL="0" indent="0">
               <a:lnSpc>
                 <a:spcPct val="135000"/>
               </a:lnSpc>
@@ -8504,7 +8744,7 @@
             <a:endParaRPr lang="en-US" sz="950" dirty="0"/>
           </a:p>
           <a:p>
-            <a:pPr indent="0" marL="0">
+            <a:pPr marL="0" indent="0">
               <a:lnSpc>
                 <a:spcPct val="135000"/>
               </a:lnSpc>
@@ -8521,7 +8761,7 @@
             <a:endParaRPr lang="en-US" sz="950" dirty="0"/>
           </a:p>
           <a:p>
-            <a:pPr indent="0" marL="0">
+            <a:pPr marL="0" indent="0">
               <a:lnSpc>
                 <a:spcPct val="135000"/>
               </a:lnSpc>
@@ -8538,7 +8778,7 @@
             <a:endParaRPr lang="en-US" sz="950" dirty="0"/>
           </a:p>
           <a:p>
-            <a:pPr indent="0" marL="0">
+            <a:pPr marL="0" indent="0">
               <a:lnSpc>
                 <a:spcPct val="135000"/>
               </a:lnSpc>
@@ -8547,7 +8787,7 @@
             <a:endParaRPr lang="en-US" sz="950" dirty="0"/>
           </a:p>
           <a:p>
-            <a:pPr indent="0" marL="0">
+            <a:pPr marL="0" indent="0">
               <a:lnSpc>
                 <a:spcPct val="135000"/>
               </a:lnSpc>
@@ -8589,6 +8829,13 @@
             <a:prstDash val="solid"/>
           </a:ln>
         </p:spPr>
+        <p:txBody>
+          <a:bodyPr/>
+          <a:lstStyle/>
+          <a:p>
+            <a:endParaRPr lang="en-US"/>
+          </a:p>
+        </p:txBody>
       </p:sp>
       <p:sp>
         <p:nvSpPr>
@@ -8611,7 +8858,7 @@
           <a:bodyPr wrap="square" lIns="0" tIns="0" rIns="0" bIns="0" rtlCol="0" anchor="ctr"/>
           <a:lstStyle/>
           <a:p>
-            <a:pPr algn="ctr" indent="0" marL="0">
+            <a:pPr marL="0" indent="0" algn="ctr">
               <a:buNone/>
             </a:pPr>
             <a:r>
@@ -8647,7 +8894,7 @@
           <a:bodyPr wrap="square" lIns="0" tIns="0" rIns="0" bIns="0" rtlCol="0" anchor="ctr"/>
           <a:lstStyle/>
           <a:p>
-            <a:pPr indent="0" marL="0">
+            <a:pPr marL="0" indent="0">
               <a:buNone/>
             </a:pPr>
             <a:r>
@@ -8678,6 +8925,7 @@
         <a:solidFill>
           <a:srgbClr val="F8F9FC"/>
         </a:solidFill>
+        <a:effectLst/>
       </p:bgPr>
     </p:bg>
     <p:spTree>
@@ -8718,6 +8966,13 @@
             <a:prstDash val="solid"/>
           </a:ln>
         </p:spPr>
+        <p:txBody>
+          <a:bodyPr/>
+          <a:lstStyle/>
+          <a:p>
+            <a:endParaRPr lang="en-US"/>
+          </a:p>
+        </p:txBody>
       </p:sp>
       <p:sp>
         <p:nvSpPr>
@@ -8740,7 +8995,7 @@
           <a:bodyPr wrap="square" lIns="0" tIns="0" rIns="0" bIns="0" rtlCol="0" anchor="ctr"/>
           <a:lstStyle/>
           <a:p>
-            <a:pPr algn="l" indent="0" marL="0">
+            <a:pPr marL="0" indent="0" algn="l">
               <a:buNone/>
             </a:pPr>
             <a:r>
@@ -8776,7 +9031,7 @@
           <a:bodyPr wrap="square" lIns="0" tIns="0" rIns="0" bIns="0" rtlCol="0" anchor="ctr"/>
           <a:lstStyle/>
           <a:p>
-            <a:pPr indent="0" marL="0">
+            <a:pPr marL="0" indent="0">
               <a:buNone/>
             </a:pPr>
             <a:r>
@@ -8815,6 +9070,13 @@
             <a:prstDash val="solid"/>
           </a:ln>
         </p:spPr>
+        <p:txBody>
+          <a:bodyPr/>
+          <a:lstStyle/>
+          <a:p>
+            <a:endParaRPr lang="en-US"/>
+          </a:p>
+        </p:txBody>
       </p:sp>
       <p:sp>
         <p:nvSpPr>
@@ -8837,7 +9099,7 @@
           <a:bodyPr wrap="square" lIns="0" tIns="0" rIns="0" bIns="0" rtlCol="0" anchor="ctr"/>
           <a:lstStyle/>
           <a:p>
-            <a:pPr algn="ctr" indent="0" marL="0">
+            <a:pPr marL="0" indent="0" algn="ctr">
               <a:buNone/>
             </a:pPr>
             <a:r>
@@ -8873,7 +9135,7 @@
           <a:bodyPr wrap="square" lIns="0" tIns="0" rIns="0" bIns="0" rtlCol="0" anchor="ctr"/>
           <a:lstStyle/>
           <a:p>
-            <a:pPr indent="0" marL="0">
+            <a:pPr marL="0" indent="0">
               <a:buNone/>
             </a:pPr>
             <a:r>
@@ -8909,7 +9171,7 @@
           <a:bodyPr wrap="square" lIns="0" tIns="0" rIns="0" bIns="0" rtlCol="0" anchor="ctr"/>
           <a:lstStyle/>
           <a:p>
-            <a:pPr indent="0" marL="0">
+            <a:pPr marL="0" indent="0">
               <a:buNone/>
             </a:pPr>
             <a:r>
@@ -8948,6 +9210,13 @@
             <a:prstDash val="solid"/>
           </a:ln>
         </p:spPr>
+        <p:txBody>
+          <a:bodyPr/>
+          <a:lstStyle/>
+          <a:p>
+            <a:endParaRPr lang="en-US"/>
+          </a:p>
+        </p:txBody>
       </p:sp>
       <p:sp>
         <p:nvSpPr>
@@ -8970,7 +9239,7 @@
           <a:bodyPr wrap="square" lIns="0" tIns="0" rIns="0" bIns="0" rtlCol="0" anchor="ctr"/>
           <a:lstStyle/>
           <a:p>
-            <a:pPr algn="ctr" indent="0" marL="0">
+            <a:pPr marL="0" indent="0" algn="ctr">
               <a:buNone/>
             </a:pPr>
             <a:r>
@@ -9006,7 +9275,7 @@
           <a:bodyPr wrap="square" lIns="0" tIns="0" rIns="0" bIns="0" rtlCol="0" anchor="ctr"/>
           <a:lstStyle/>
           <a:p>
-            <a:pPr indent="0" marL="0">
+            <a:pPr marL="0" indent="0">
               <a:buNone/>
             </a:pPr>
             <a:r>
@@ -9043,6 +9312,13 @@
             <a:prstDash val="solid"/>
           </a:ln>
         </p:spPr>
+        <p:txBody>
+          <a:bodyPr/>
+          <a:lstStyle/>
+          <a:p>
+            <a:endParaRPr lang="en-US"/>
+          </a:p>
+        </p:txBody>
       </p:sp>
       <p:sp>
         <p:nvSpPr>
@@ -9065,7 +9341,7 @@
           <a:bodyPr wrap="square" lIns="0" tIns="0" rIns="0" bIns="0" rtlCol="0" anchor="ctr"/>
           <a:lstStyle/>
           <a:p>
-            <a:pPr indent="0" marL="0">
+            <a:pPr marL="0" indent="0">
               <a:buNone/>
             </a:pPr>
             <a:r>
@@ -9101,7 +9377,7 @@
           <a:bodyPr wrap="square" lIns="0" tIns="0" rIns="0" bIns="0" rtlCol="0" anchor="ctr"/>
           <a:lstStyle/>
           <a:p>
-            <a:pPr indent="0" marL="0">
+            <a:pPr marL="0" indent="0">
               <a:lnSpc>
                 <a:spcPct val="130000"/>
               </a:lnSpc>
@@ -9143,6 +9419,13 @@
             <a:prstDash val="solid"/>
           </a:ln>
         </p:spPr>
+        <p:txBody>
+          <a:bodyPr/>
+          <a:lstStyle/>
+          <a:p>
+            <a:endParaRPr lang="en-US"/>
+          </a:p>
+        </p:txBody>
       </p:sp>
       <p:sp>
         <p:nvSpPr>
@@ -9165,7 +9448,7 @@
           <a:bodyPr wrap="square" lIns="0" tIns="0" rIns="0" bIns="0" rtlCol="0" anchor="ctr"/>
           <a:lstStyle/>
           <a:p>
-            <a:pPr indent="0" marL="0">
+            <a:pPr marL="0" indent="0">
               <a:buNone/>
             </a:pPr>
             <a:r>
@@ -9201,7 +9484,7 @@
           <a:bodyPr wrap="square" lIns="0" tIns="0" rIns="0" bIns="0" rtlCol="0" anchor="ctr"/>
           <a:lstStyle/>
           <a:p>
-            <a:pPr indent="0" marL="0">
+            <a:pPr marL="0" indent="0">
               <a:lnSpc>
                 <a:spcPct val="130000"/>
               </a:lnSpc>
@@ -9218,7 +9501,7 @@
             <a:endParaRPr lang="en-US" sz="900" dirty="0"/>
           </a:p>
           <a:p>
-            <a:pPr indent="0" marL="0">
+            <a:pPr marL="0" indent="0">
               <a:lnSpc>
                 <a:spcPct val="130000"/>
               </a:lnSpc>
@@ -9227,7 +9510,7 @@
             <a:endParaRPr lang="en-US" sz="900" dirty="0"/>
           </a:p>
           <a:p>
-            <a:pPr indent="0" marL="0">
+            <a:pPr marL="0" indent="0">
               <a:lnSpc>
                 <a:spcPct val="130000"/>
               </a:lnSpc>
@@ -9244,7 +9527,7 @@
             <a:endParaRPr lang="en-US" sz="900" dirty="0"/>
           </a:p>
           <a:p>
-            <a:pPr indent="0" marL="0">
+            <a:pPr marL="0" indent="0">
               <a:lnSpc>
                 <a:spcPct val="130000"/>
               </a:lnSpc>
@@ -9253,7 +9536,7 @@
             <a:endParaRPr lang="en-US" sz="900" dirty="0"/>
           </a:p>
           <a:p>
-            <a:pPr indent="0" marL="0">
+            <a:pPr marL="0" indent="0">
               <a:lnSpc>
                 <a:spcPct val="130000"/>
               </a:lnSpc>
@@ -9295,6 +9578,13 @@
             <a:prstDash val="solid"/>
           </a:ln>
         </p:spPr>
+        <p:txBody>
+          <a:bodyPr/>
+          <a:lstStyle/>
+          <a:p>
+            <a:endParaRPr lang="en-US"/>
+          </a:p>
+        </p:txBody>
       </p:sp>
       <p:sp>
         <p:nvSpPr>
@@ -9317,7 +9607,7 @@
           <a:bodyPr wrap="square" lIns="0" tIns="0" rIns="0" bIns="0" rtlCol="0" anchor="ctr"/>
           <a:lstStyle/>
           <a:p>
-            <a:pPr indent="0" marL="0">
+            <a:pPr marL="0" indent="0">
               <a:buNone/>
             </a:pPr>
             <a:r>
@@ -9353,7 +9643,7 @@
           <a:bodyPr wrap="square" lIns="0" tIns="0" rIns="0" bIns="0" rtlCol="0" anchor="ctr"/>
           <a:lstStyle/>
           <a:p>
-            <a:pPr indent="0" marL="0">
+            <a:pPr marL="0" indent="0">
               <a:buNone/>
             </a:pPr>
             <a:r>
@@ -9384,6 +9674,7 @@
         <a:solidFill>
           <a:srgbClr val="F8F9FC"/>
         </a:solidFill>
+        <a:effectLst/>
       </p:bgPr>
     </p:bg>
     <p:spTree>
@@ -9424,6 +9715,13 @@
             <a:prstDash val="solid"/>
           </a:ln>
         </p:spPr>
+        <p:txBody>
+          <a:bodyPr/>
+          <a:lstStyle/>
+          <a:p>
+            <a:endParaRPr lang="en-US"/>
+          </a:p>
+        </p:txBody>
       </p:sp>
       <p:sp>
         <p:nvSpPr>
@@ -9446,7 +9744,7 @@
           <a:bodyPr wrap="square" lIns="0" tIns="0" rIns="0" bIns="0" rtlCol="0" anchor="ctr"/>
           <a:lstStyle/>
           <a:p>
-            <a:pPr algn="l" indent="0" marL="0">
+            <a:pPr marL="0" indent="0" algn="l">
               <a:buNone/>
             </a:pPr>
             <a:r>
@@ -9482,7 +9780,7 @@
           <a:bodyPr wrap="square" lIns="0" tIns="0" rIns="0" bIns="0" rtlCol="0" anchor="ctr"/>
           <a:lstStyle/>
           <a:p>
-            <a:pPr indent="0" marL="0">
+            <a:pPr marL="0" indent="0">
               <a:buNone/>
             </a:pPr>
             <a:r>
@@ -9521,6 +9819,13 @@
             <a:prstDash val="solid"/>
           </a:ln>
         </p:spPr>
+        <p:txBody>
+          <a:bodyPr/>
+          <a:lstStyle/>
+          <a:p>
+            <a:endParaRPr lang="en-US"/>
+          </a:p>
+        </p:txBody>
       </p:sp>
       <p:sp>
         <p:nvSpPr>
@@ -9543,7 +9848,7 @@
           <a:bodyPr wrap="square" lIns="0" tIns="0" rIns="0" bIns="0" rtlCol="0" anchor="ctr"/>
           <a:lstStyle/>
           <a:p>
-            <a:pPr algn="ctr" indent="0" marL="0">
+            <a:pPr marL="0" indent="0" algn="ctr">
               <a:buNone/>
             </a:pPr>
             <a:r>
@@ -9579,7 +9884,7 @@
           <a:bodyPr wrap="square" lIns="0" tIns="0" rIns="0" bIns="0" rtlCol="0" anchor="ctr"/>
           <a:lstStyle/>
           <a:p>
-            <a:pPr indent="0" marL="0">
+            <a:pPr marL="0" indent="0">
               <a:lnSpc>
                 <a:spcPct val="130000"/>
               </a:lnSpc>
@@ -9621,6 +9926,13 @@
             <a:prstDash val="solid"/>
           </a:ln>
         </p:spPr>
+        <p:txBody>
+          <a:bodyPr/>
+          <a:lstStyle/>
+          <a:p>
+            <a:endParaRPr lang="en-US"/>
+          </a:p>
+        </p:txBody>
       </p:sp>
       <p:sp>
         <p:nvSpPr>
@@ -9643,7 +9955,7 @@
           <a:bodyPr wrap="square" lIns="0" tIns="0" rIns="0" bIns="0" rtlCol="0" anchor="ctr"/>
           <a:lstStyle/>
           <a:p>
-            <a:pPr algn="ctr" indent="0" marL="0">
+            <a:pPr marL="0" indent="0" algn="ctr">
               <a:buNone/>
             </a:pPr>
             <a:r>
@@ -9679,7 +9991,7 @@
           <a:bodyPr wrap="square" lIns="0" tIns="0" rIns="0" bIns="0" rtlCol="0" anchor="ctr"/>
           <a:lstStyle/>
           <a:p>
-            <a:pPr algn="ctr" indent="0" marL="0">
+            <a:pPr marL="0" indent="0" algn="ctr">
               <a:buNone/>
             </a:pPr>
             <a:r>
@@ -9718,6 +10030,13 @@
             <a:prstDash val="solid"/>
           </a:ln>
         </p:spPr>
+        <p:txBody>
+          <a:bodyPr/>
+          <a:lstStyle/>
+          <a:p>
+            <a:endParaRPr lang="en-US"/>
+          </a:p>
+        </p:txBody>
       </p:sp>
       <p:sp>
         <p:nvSpPr>
@@ -9740,7 +10059,7 @@
           <a:bodyPr wrap="square" lIns="0" tIns="0" rIns="0" bIns="0" rtlCol="0" anchor="ctr"/>
           <a:lstStyle/>
           <a:p>
-            <a:pPr algn="ctr" indent="0" marL="0">
+            <a:pPr marL="0" indent="0" algn="ctr">
               <a:buNone/>
             </a:pPr>
             <a:r>
@@ -9776,7 +10095,7 @@
           <a:bodyPr wrap="square" lIns="0" tIns="0" rIns="0" bIns="0" rtlCol="0" anchor="ctr"/>
           <a:lstStyle/>
           <a:p>
-            <a:pPr algn="ctr" indent="0" marL="0">
+            <a:pPr marL="0" indent="0" algn="ctr">
               <a:buNone/>
             </a:pPr>
             <a:r>
@@ -9815,6 +10134,13 @@
             <a:prstDash val="solid"/>
           </a:ln>
         </p:spPr>
+        <p:txBody>
+          <a:bodyPr/>
+          <a:lstStyle/>
+          <a:p>
+            <a:endParaRPr lang="en-US"/>
+          </a:p>
+        </p:txBody>
       </p:sp>
       <p:sp>
         <p:nvSpPr>
@@ -9837,7 +10163,7 @@
           <a:bodyPr wrap="square" lIns="0" tIns="0" rIns="0" bIns="0" rtlCol="0" anchor="ctr"/>
           <a:lstStyle/>
           <a:p>
-            <a:pPr algn="ctr" indent="0" marL="0">
+            <a:pPr marL="0" indent="0" algn="ctr">
               <a:buNone/>
             </a:pPr>
             <a:r>
@@ -9873,7 +10199,7 @@
           <a:bodyPr wrap="square" lIns="0" tIns="0" rIns="0" bIns="0" rtlCol="0" anchor="ctr"/>
           <a:lstStyle/>
           <a:p>
-            <a:pPr algn="ctr" indent="0" marL="0">
+            <a:pPr marL="0" indent="0" algn="ctr">
               <a:buNone/>
             </a:pPr>
             <a:r>
@@ -9912,6 +10238,13 @@
             <a:prstDash val="solid"/>
           </a:ln>
         </p:spPr>
+        <p:txBody>
+          <a:bodyPr/>
+          <a:lstStyle/>
+          <a:p>
+            <a:endParaRPr lang="en-US"/>
+          </a:p>
+        </p:txBody>
       </p:sp>
       <p:sp>
         <p:nvSpPr>
@@ -9934,7 +10267,7 @@
           <a:bodyPr wrap="square" lIns="0" tIns="0" rIns="0" bIns="0" rtlCol="0" anchor="ctr"/>
           <a:lstStyle/>
           <a:p>
-            <a:pPr algn="ctr" indent="0" marL="0">
+            <a:pPr marL="0" indent="0" algn="ctr">
               <a:buNone/>
             </a:pPr>
             <a:r>
@@ -9970,7 +10303,7 @@
           <a:bodyPr wrap="square" lIns="0" tIns="0" rIns="0" bIns="0" rtlCol="0" anchor="ctr"/>
           <a:lstStyle/>
           <a:p>
-            <a:pPr algn="ctr" indent="0" marL="0">
+            <a:pPr marL="0" indent="0" algn="ctr">
               <a:buNone/>
             </a:pPr>
             <a:r>
@@ -10009,6 +10342,13 @@
             <a:prstDash val="solid"/>
           </a:ln>
         </p:spPr>
+        <p:txBody>
+          <a:bodyPr/>
+          <a:lstStyle/>
+          <a:p>
+            <a:endParaRPr lang="en-US"/>
+          </a:p>
+        </p:txBody>
       </p:sp>
       <p:sp>
         <p:nvSpPr>
@@ -10031,7 +10371,7 @@
           <a:bodyPr wrap="square" lIns="0" tIns="0" rIns="0" bIns="0" rtlCol="0" anchor="ctr"/>
           <a:lstStyle/>
           <a:p>
-            <a:pPr algn="ctr" indent="0" marL="0">
+            <a:pPr marL="0" indent="0" algn="ctr">
               <a:buNone/>
             </a:pPr>
             <a:r>
@@ -10067,7 +10407,7 @@
           <a:bodyPr wrap="square" lIns="0" tIns="0" rIns="0" bIns="0" rtlCol="0" anchor="ctr"/>
           <a:lstStyle/>
           <a:p>
-            <a:pPr algn="ctr" indent="0" marL="0">
+            <a:pPr marL="0" indent="0" algn="ctr">
               <a:buNone/>
             </a:pPr>
             <a:r>
@@ -10103,7 +10443,7 @@
           <a:bodyPr wrap="square" lIns="0" tIns="0" rIns="0" bIns="0" rtlCol="0" anchor="ctr"/>
           <a:lstStyle/>
           <a:p>
-            <a:pPr indent="0" marL="0">
+            <a:pPr marL="0" indent="0">
               <a:buNone/>
             </a:pPr>
             <a:r>
@@ -10140,6 +10480,13 @@
             <a:prstDash val="solid"/>
           </a:ln>
         </p:spPr>
+        <p:txBody>
+          <a:bodyPr/>
+          <a:lstStyle/>
+          <a:p>
+            <a:endParaRPr lang="en-US"/>
+          </a:p>
+        </p:txBody>
       </p:sp>
       <p:sp>
         <p:nvSpPr>
@@ -10162,7 +10509,7 @@
           <a:bodyPr wrap="square" lIns="0" tIns="0" rIns="0" bIns="0" rtlCol="0" anchor="ctr"/>
           <a:lstStyle/>
           <a:p>
-            <a:pPr indent="0" marL="0">
+            <a:pPr marL="0" indent="0">
               <a:buNone/>
             </a:pPr>
             <a:r>
@@ -10198,7 +10545,7 @@
           <a:bodyPr wrap="square" lIns="0" tIns="0" rIns="0" bIns="0" rtlCol="0" anchor="ctr"/>
           <a:lstStyle/>
           <a:p>
-            <a:pPr indent="0" marL="0">
+            <a:pPr marL="0" indent="0">
               <a:buNone/>
             </a:pPr>
             <a:r>
@@ -10237,6 +10584,13 @@
             <a:prstDash val="solid"/>
           </a:ln>
         </p:spPr>
+        <p:txBody>
+          <a:bodyPr/>
+          <a:lstStyle/>
+          <a:p>
+            <a:endParaRPr lang="en-US"/>
+          </a:p>
+        </p:txBody>
       </p:sp>
       <p:sp>
         <p:nvSpPr>
@@ -10259,7 +10613,7 @@
           <a:bodyPr wrap="square" lIns="0" tIns="0" rIns="0" bIns="0" rtlCol="0" anchor="ctr"/>
           <a:lstStyle/>
           <a:p>
-            <a:pPr indent="0" marL="0">
+            <a:pPr marL="0" indent="0">
               <a:buNone/>
             </a:pPr>
             <a:r>
@@ -10298,6 +10652,13 @@
             <a:prstDash val="solid"/>
           </a:ln>
         </p:spPr>
+        <p:txBody>
+          <a:bodyPr/>
+          <a:lstStyle/>
+          <a:p>
+            <a:endParaRPr lang="en-US"/>
+          </a:p>
+        </p:txBody>
       </p:sp>
       <p:sp>
         <p:nvSpPr>
@@ -10320,7 +10681,7 @@
           <a:bodyPr wrap="square" lIns="0" tIns="0" rIns="0" bIns="0" rtlCol="0" anchor="ctr"/>
           <a:lstStyle/>
           <a:p>
-            <a:pPr indent="0" marL="0">
+            <a:pPr marL="0" indent="0">
               <a:buNone/>
             </a:pPr>
             <a:r>
@@ -10359,6 +10720,13 @@
             <a:prstDash val="solid"/>
           </a:ln>
         </p:spPr>
+        <p:txBody>
+          <a:bodyPr/>
+          <a:lstStyle/>
+          <a:p>
+            <a:endParaRPr lang="en-US"/>
+          </a:p>
+        </p:txBody>
       </p:sp>
       <p:sp>
         <p:nvSpPr>
@@ -10381,7 +10749,7 @@
           <a:bodyPr wrap="square" lIns="0" tIns="0" rIns="0" bIns="0" rtlCol="0" anchor="ctr"/>
           <a:lstStyle/>
           <a:p>
-            <a:pPr indent="0" marL="0">
+            <a:pPr marL="0" indent="0">
               <a:buNone/>
             </a:pPr>
             <a:r>
@@ -10420,6 +10788,13 @@
             <a:prstDash val="solid"/>
           </a:ln>
         </p:spPr>
+        <p:txBody>
+          <a:bodyPr/>
+          <a:lstStyle/>
+          <a:p>
+            <a:endParaRPr lang="en-US"/>
+          </a:p>
+        </p:txBody>
       </p:sp>
       <p:sp>
         <p:nvSpPr>
@@ -10442,7 +10817,7 @@
           <a:bodyPr wrap="square" lIns="0" tIns="0" rIns="0" bIns="0" rtlCol="0" anchor="ctr"/>
           <a:lstStyle/>
           <a:p>
-            <a:pPr indent="0" marL="0">
+            <a:pPr marL="0" indent="0">
               <a:buNone/>
             </a:pPr>
             <a:r>
@@ -10481,6 +10856,13 @@
             <a:prstDash val="solid"/>
           </a:ln>
         </p:spPr>
+        <p:txBody>
+          <a:bodyPr/>
+          <a:lstStyle/>
+          <a:p>
+            <a:endParaRPr lang="en-US"/>
+          </a:p>
+        </p:txBody>
       </p:sp>
       <p:sp>
         <p:nvSpPr>
@@ -10503,7 +10885,7 @@
           <a:bodyPr wrap="square" lIns="0" tIns="0" rIns="0" bIns="0" rtlCol="0" anchor="ctr"/>
           <a:lstStyle/>
           <a:p>
-            <a:pPr indent="0" marL="0">
+            <a:pPr marL="0" indent="0">
               <a:buNone/>
             </a:pPr>
             <a:r>
@@ -10542,6 +10924,13 @@
             <a:prstDash val="solid"/>
           </a:ln>
         </p:spPr>
+        <p:txBody>
+          <a:bodyPr/>
+          <a:lstStyle/>
+          <a:p>
+            <a:endParaRPr lang="en-US"/>
+          </a:p>
+        </p:txBody>
       </p:sp>
       <p:sp>
         <p:nvSpPr>
@@ -10564,7 +10953,7 @@
           <a:bodyPr wrap="square" lIns="0" tIns="0" rIns="0" bIns="0" rtlCol="0" anchor="ctr"/>
           <a:lstStyle/>
           <a:p>
-            <a:pPr indent="0" marL="0">
+            <a:pPr marL="0" indent="0">
               <a:buNone/>
             </a:pPr>
             <a:r>
@@ -10603,6 +10992,13 @@
             <a:prstDash val="solid"/>
           </a:ln>
         </p:spPr>
+        <p:txBody>
+          <a:bodyPr/>
+          <a:lstStyle/>
+          <a:p>
+            <a:endParaRPr lang="en-US"/>
+          </a:p>
+        </p:txBody>
       </p:sp>
       <p:sp>
         <p:nvSpPr>
@@ -10625,7 +11021,7 @@
           <a:bodyPr wrap="square" lIns="0" tIns="0" rIns="0" bIns="0" rtlCol="0" anchor="ctr"/>
           <a:lstStyle/>
           <a:p>
-            <a:pPr indent="0" marL="0">
+            <a:pPr marL="0" indent="0">
               <a:buNone/>
             </a:pPr>
             <a:r>
@@ -10664,6 +11060,13 @@
             <a:prstDash val="solid"/>
           </a:ln>
         </p:spPr>
+        <p:txBody>
+          <a:bodyPr/>
+          <a:lstStyle/>
+          <a:p>
+            <a:endParaRPr lang="en-US"/>
+          </a:p>
+        </p:txBody>
       </p:sp>
       <p:sp>
         <p:nvSpPr>
@@ -10686,7 +11089,7 @@
           <a:bodyPr wrap="square" lIns="0" tIns="0" rIns="0" bIns="0" rtlCol="0" anchor="ctr"/>
           <a:lstStyle/>
           <a:p>
-            <a:pPr indent="0" marL="0">
+            <a:pPr marL="0" indent="0">
               <a:buNone/>
             </a:pPr>
             <a:r>
@@ -10725,6 +11128,13 @@
             <a:prstDash val="solid"/>
           </a:ln>
         </p:spPr>
+        <p:txBody>
+          <a:bodyPr/>
+          <a:lstStyle/>
+          <a:p>
+            <a:endParaRPr lang="en-US"/>
+          </a:p>
+        </p:txBody>
       </p:sp>
       <p:sp>
         <p:nvSpPr>
@@ -10747,7 +11157,7 @@
           <a:bodyPr wrap="square" lIns="0" tIns="0" rIns="0" bIns="0" rtlCol="0" anchor="ctr"/>
           <a:lstStyle/>
           <a:p>
-            <a:pPr indent="0" marL="0">
+            <a:pPr marL="0" indent="0">
               <a:buNone/>
             </a:pPr>
             <a:r>
@@ -10786,6 +11196,13 @@
             <a:prstDash val="solid"/>
           </a:ln>
         </p:spPr>
+        <p:txBody>
+          <a:bodyPr/>
+          <a:lstStyle/>
+          <a:p>
+            <a:endParaRPr lang="en-US"/>
+          </a:p>
+        </p:txBody>
       </p:sp>
       <p:sp>
         <p:nvSpPr>
@@ -10808,7 +11225,7 @@
           <a:bodyPr wrap="square" lIns="0" tIns="0" rIns="0" bIns="0" rtlCol="0" anchor="ctr"/>
           <a:lstStyle/>
           <a:p>
-            <a:pPr indent="0" marL="0">
+            <a:pPr marL="0" indent="0">
               <a:buNone/>
             </a:pPr>
             <a:r>
@@ -10844,7 +11261,7 @@
           <a:bodyPr wrap="square" lIns="0" tIns="0" rIns="0" bIns="0" rtlCol="0" anchor="ctr"/>
           <a:lstStyle/>
           <a:p>
-            <a:pPr indent="0" marL="0">
+            <a:pPr marL="0" indent="0">
               <a:buNone/>
             </a:pPr>
             <a:r>
@@ -10878,13 +11295,20 @@
           </a:solidFill>
           <a:ln/>
           <a:effectLst>
-            <a:outerShdw sx="100000" sy="100000" kx="0" ky="0" algn="bl" rotWithShape="0" blurRad="50800" dist="12700" dir="8100000">
+            <a:outerShdw blurRad="50800" dist="12700" dir="8100000" algn="bl" rotWithShape="0">
               <a:srgbClr val="000000">
                 <a:alpha val="10000"/>
               </a:srgbClr>
             </a:outerShdw>
           </a:effectLst>
         </p:spPr>
+        <p:txBody>
+          <a:bodyPr/>
+          <a:lstStyle/>
+          <a:p>
+            <a:endParaRPr lang="en-US"/>
+          </a:p>
+        </p:txBody>
       </p:sp>
       <p:sp>
         <p:nvSpPr>
@@ -10907,7 +11331,7 @@
           <a:bodyPr wrap="square" lIns="0" tIns="0" rIns="0" bIns="0" rtlCol="0" anchor="ctr"/>
           <a:lstStyle/>
           <a:p>
-            <a:pPr algn="ctr" indent="0" marL="0">
+            <a:pPr marL="0" indent="0" algn="ctr">
               <a:buNone/>
             </a:pPr>
             <a:r>
@@ -10943,7 +11367,7 @@
           <a:bodyPr wrap="square" lIns="0" tIns="0" rIns="0" bIns="0" rtlCol="0" anchor="ctr"/>
           <a:lstStyle/>
           <a:p>
-            <a:pPr algn="ctr" indent="0" marL="0">
+            <a:pPr marL="0" indent="0" algn="ctr">
               <a:buNone/>
             </a:pPr>
             <a:r>
@@ -10977,13 +11401,20 @@
           </a:solidFill>
           <a:ln/>
           <a:effectLst>
-            <a:outerShdw sx="100000" sy="100000" kx="0" ky="0" algn="bl" rotWithShape="0" blurRad="50800" dist="12700" dir="8100000">
+            <a:outerShdw blurRad="50800" dist="12700" dir="8100000" algn="bl" rotWithShape="0">
               <a:srgbClr val="000000">
                 <a:alpha val="10000"/>
               </a:srgbClr>
             </a:outerShdw>
           </a:effectLst>
         </p:spPr>
+        <p:txBody>
+          <a:bodyPr/>
+          <a:lstStyle/>
+          <a:p>
+            <a:endParaRPr lang="en-US"/>
+          </a:p>
+        </p:txBody>
       </p:sp>
       <p:sp>
         <p:nvSpPr>
@@ -11006,7 +11437,7 @@
           <a:bodyPr wrap="square" lIns="0" tIns="0" rIns="0" bIns="0" rtlCol="0" anchor="ctr"/>
           <a:lstStyle/>
           <a:p>
-            <a:pPr algn="ctr" indent="0" marL="0">
+            <a:pPr marL="0" indent="0" algn="ctr">
               <a:buNone/>
             </a:pPr>
             <a:r>
@@ -11042,7 +11473,7 @@
           <a:bodyPr wrap="square" lIns="0" tIns="0" rIns="0" bIns="0" rtlCol="0" anchor="ctr"/>
           <a:lstStyle/>
           <a:p>
-            <a:pPr algn="ctr" indent="0" marL="0">
+            <a:pPr marL="0" indent="0" algn="ctr">
               <a:buNone/>
             </a:pPr>
             <a:r>
@@ -11076,13 +11507,20 @@
           </a:solidFill>
           <a:ln/>
           <a:effectLst>
-            <a:outerShdw sx="100000" sy="100000" kx="0" ky="0" algn="bl" rotWithShape="0" blurRad="50800" dist="12700" dir="8100000">
+            <a:outerShdw blurRad="50800" dist="12700" dir="8100000" algn="bl" rotWithShape="0">
               <a:srgbClr val="000000">
                 <a:alpha val="10000"/>
               </a:srgbClr>
             </a:outerShdw>
           </a:effectLst>
         </p:spPr>
+        <p:txBody>
+          <a:bodyPr/>
+          <a:lstStyle/>
+          <a:p>
+            <a:endParaRPr lang="en-US"/>
+          </a:p>
+        </p:txBody>
       </p:sp>
       <p:sp>
         <p:nvSpPr>
@@ -11105,7 +11543,7 @@
           <a:bodyPr wrap="square" lIns="0" tIns="0" rIns="0" bIns="0" rtlCol="0" anchor="ctr"/>
           <a:lstStyle/>
           <a:p>
-            <a:pPr algn="ctr" indent="0" marL="0">
+            <a:pPr marL="0" indent="0" algn="ctr">
               <a:buNone/>
             </a:pPr>
             <a:r>
@@ -11141,7 +11579,7 @@
           <a:bodyPr wrap="square" lIns="0" tIns="0" rIns="0" bIns="0" rtlCol="0" anchor="ctr"/>
           <a:lstStyle/>
           <a:p>
-            <a:pPr algn="ctr" indent="0" marL="0">
+            <a:pPr marL="0" indent="0" algn="ctr">
               <a:buNone/>
             </a:pPr>
             <a:r>
@@ -11177,7 +11615,7 @@
           <a:bodyPr wrap="square" lIns="0" tIns="0" rIns="0" bIns="0" rtlCol="0" anchor="ctr"/>
           <a:lstStyle/>
           <a:p>
-            <a:pPr indent="0" marL="0">
+            <a:pPr marL="0" indent="0">
               <a:buNone/>
             </a:pPr>
             <a:r>
@@ -11493,4 +11931,319 @@
     </a:ext>
   </a:extLst>
 </a:theme>
+</file>
+
+<file path=ppt/theme/theme2.xml><?xml version="1.0" encoding="utf-8"?>
+<a:theme xmlns:a="http://schemas.openxmlformats.org/drawingml/2006/main" name="Office Theme">
+  <a:themeElements>
+    <a:clrScheme name="Office">
+      <a:dk1>
+        <a:sysClr val="windowText" lastClr="000000"/>
+      </a:dk1>
+      <a:lt1>
+        <a:sysClr val="window" lastClr="FFFFFF"/>
+      </a:lt1>
+      <a:dk2>
+        <a:srgbClr val="0E2841"/>
+      </a:dk2>
+      <a:lt2>
+        <a:srgbClr val="E8E8E8"/>
+      </a:lt2>
+      <a:accent1>
+        <a:srgbClr val="156082"/>
+      </a:accent1>
+      <a:accent2>
+        <a:srgbClr val="E97132"/>
+      </a:accent2>
+      <a:accent3>
+        <a:srgbClr val="196B24"/>
+      </a:accent3>
+      <a:accent4>
+        <a:srgbClr val="0F9ED5"/>
+      </a:accent4>
+      <a:accent5>
+        <a:srgbClr val="A02B93"/>
+      </a:accent5>
+      <a:accent6>
+        <a:srgbClr val="4EA72E"/>
+      </a:accent6>
+      <a:hlink>
+        <a:srgbClr val="467886"/>
+      </a:hlink>
+      <a:folHlink>
+        <a:srgbClr val="96607D"/>
+      </a:folHlink>
+    </a:clrScheme>
+    <a:fontScheme name="Office">
+      <a:majorFont>
+        <a:latin typeface="Aptos Display" panose="02110004020202020204"/>
+        <a:ea typeface=""/>
+        <a:cs typeface=""/>
+        <a:font script="Jpan" typeface="游ゴシック Light"/>
+        <a:font script="Hang" typeface="맑은 고딕"/>
+        <a:font script="Hans" typeface="等线 Light"/>
+        <a:font script="Hant" typeface="新細明體"/>
+        <a:font script="Arab" typeface="Times New Roman"/>
+        <a:font script="Hebr" typeface="Times New Roman"/>
+        <a:font script="Thai" typeface="Angsana New"/>
+        <a:font script="Ethi" typeface="Nyala"/>
+        <a:font script="Beng" typeface="Vrinda"/>
+        <a:font script="Gujr" typeface="Shruti"/>
+        <a:font script="Khmr" typeface="MoolBoran"/>
+        <a:font script="Knda" typeface="Tunga"/>
+        <a:font script="Guru" typeface="Raavi"/>
+        <a:font script="Cans" typeface="Euphemia"/>
+        <a:font script="Cher" typeface="Plantagenet Cherokee"/>
+        <a:font script="Yiii" typeface="Microsoft Yi Baiti"/>
+        <a:font script="Tibt" typeface="Microsoft Himalaya"/>
+        <a:font script="Thaa" typeface="MV Boli"/>
+        <a:font script="Deva" typeface="Mangal"/>
+        <a:font script="Telu" typeface="Gautami"/>
+        <a:font script="Taml" typeface="Latha"/>
+        <a:font script="Syrc" typeface="Estrangelo Edessa"/>
+        <a:font script="Orya" typeface="Kalinga"/>
+        <a:font script="Mlym" typeface="Kartika"/>
+        <a:font script="Laoo" typeface="DokChampa"/>
+        <a:font script="Sinh" typeface="Iskoola Pota"/>
+        <a:font script="Mong" typeface="Mongolian Baiti"/>
+        <a:font script="Viet" typeface="Times New Roman"/>
+        <a:font script="Uigh" typeface="Microsoft Uighur"/>
+        <a:font script="Geor" typeface="Sylfaen"/>
+        <a:font script="Armn" typeface="Arial"/>
+        <a:font script="Bugi" typeface="Leelawadee UI"/>
+        <a:font script="Bopo" typeface="Microsoft JhengHei"/>
+        <a:font script="Java" typeface="Javanese Text"/>
+        <a:font script="Lisu" typeface="Segoe UI"/>
+        <a:font script="Mymr" typeface="Myanmar Text"/>
+        <a:font script="Nkoo" typeface="Ebrima"/>
+        <a:font script="Olck" typeface="Nirmala UI"/>
+        <a:font script="Osma" typeface="Ebrima"/>
+        <a:font script="Phag" typeface="Phagspa"/>
+        <a:font script="Syrn" typeface="Estrangelo Edessa"/>
+        <a:font script="Syrj" typeface="Estrangelo Edessa"/>
+        <a:font script="Syre" typeface="Estrangelo Edessa"/>
+        <a:font script="Sora" typeface="Nirmala UI"/>
+        <a:font script="Tale" typeface="Microsoft Tai Le"/>
+        <a:font script="Talu" typeface="Microsoft New Tai Lue"/>
+        <a:font script="Tfng" typeface="Ebrima"/>
+      </a:majorFont>
+      <a:minorFont>
+        <a:latin typeface="Aptos" panose="02110004020202020204"/>
+        <a:ea typeface=""/>
+        <a:cs typeface=""/>
+        <a:font script="Jpan" typeface="游ゴシック"/>
+        <a:font script="Hang" typeface="맑은 고딕"/>
+        <a:font script="Hans" typeface="等线"/>
+        <a:font script="Hant" typeface="新細明體"/>
+        <a:font script="Arab" typeface="Arial"/>
+        <a:font script="Hebr" typeface="Arial"/>
+        <a:font script="Thai" typeface="Cordia New"/>
+        <a:font script="Ethi" typeface="Nyala"/>
+        <a:font script="Beng" typeface="Vrinda"/>
+        <a:font script="Gujr" typeface="Shruti"/>
+        <a:font script="Khmr" typeface="DaunPenh"/>
+        <a:font script="Knda" typeface="Tunga"/>
+        <a:font script="Guru" typeface="Raavi"/>
+        <a:font script="Cans" typeface="Euphemia"/>
+        <a:font script="Cher" typeface="Plantagenet Cherokee"/>
+        <a:font script="Yiii" typeface="Microsoft Yi Baiti"/>
+        <a:font script="Tibt" typeface="Microsoft Himalaya"/>
+        <a:font script="Thaa" typeface="MV Boli"/>
+        <a:font script="Deva" typeface="Mangal"/>
+        <a:font script="Telu" typeface="Gautami"/>
+        <a:font script="Taml" typeface="Latha"/>
+        <a:font script="Syrc" typeface="Estrangelo Edessa"/>
+        <a:font script="Orya" typeface="Kalinga"/>
+        <a:font script="Mlym" typeface="Kartika"/>
+        <a:font script="Laoo" typeface="DokChampa"/>
+        <a:font script="Sinh" typeface="Iskoola Pota"/>
+        <a:font script="Mong" typeface="Mongolian Baiti"/>
+        <a:font script="Viet" typeface="Arial"/>
+        <a:font script="Uigh" typeface="Microsoft Uighur"/>
+        <a:font script="Geor" typeface="Sylfaen"/>
+        <a:font script="Armn" typeface="Arial"/>
+        <a:font script="Bugi" typeface="Leelawadee UI"/>
+        <a:font script="Bopo" typeface="Microsoft JhengHei"/>
+        <a:font script="Java" typeface="Javanese Text"/>
+        <a:font script="Lisu" typeface="Segoe UI"/>
+        <a:font script="Mymr" typeface="Myanmar Text"/>
+        <a:font script="Nkoo" typeface="Ebrima"/>
+        <a:font script="Olck" typeface="Nirmala UI"/>
+        <a:font script="Osma" typeface="Ebrima"/>
+        <a:font script="Phag" typeface="Phagspa"/>
+        <a:font script="Syrn" typeface="Estrangelo Edessa"/>
+        <a:font script="Syrj" typeface="Estrangelo Edessa"/>
+        <a:font script="Syre" typeface="Estrangelo Edessa"/>
+        <a:font script="Sora" typeface="Nirmala UI"/>
+        <a:font script="Tale" typeface="Microsoft Tai Le"/>
+        <a:font script="Talu" typeface="Microsoft New Tai Lue"/>
+        <a:font script="Tfng" typeface="Ebrima"/>
+      </a:minorFont>
+    </a:fontScheme>
+    <a:fmtScheme name="Office">
+      <a:fillStyleLst>
+        <a:solidFill>
+          <a:schemeClr val="phClr"/>
+        </a:solidFill>
+        <a:gradFill rotWithShape="1">
+          <a:gsLst>
+            <a:gs pos="0">
+              <a:schemeClr val="phClr">
+                <a:lumMod val="110000"/>
+                <a:satMod val="105000"/>
+                <a:tint val="67000"/>
+              </a:schemeClr>
+            </a:gs>
+            <a:gs pos="50000">
+              <a:schemeClr val="phClr">
+                <a:lumMod val="105000"/>
+                <a:satMod val="103000"/>
+                <a:tint val="73000"/>
+              </a:schemeClr>
+            </a:gs>
+            <a:gs pos="100000">
+              <a:schemeClr val="phClr">
+                <a:lumMod val="105000"/>
+                <a:satMod val="109000"/>
+                <a:tint val="81000"/>
+              </a:schemeClr>
+            </a:gs>
+          </a:gsLst>
+          <a:lin ang="5400000" scaled="0"/>
+        </a:gradFill>
+        <a:gradFill rotWithShape="1">
+          <a:gsLst>
+            <a:gs pos="0">
+              <a:schemeClr val="phClr">
+                <a:satMod val="103000"/>
+                <a:lumMod val="102000"/>
+                <a:tint val="94000"/>
+              </a:schemeClr>
+            </a:gs>
+            <a:gs pos="50000">
+              <a:schemeClr val="phClr">
+                <a:satMod val="110000"/>
+                <a:lumMod val="100000"/>
+                <a:shade val="100000"/>
+              </a:schemeClr>
+            </a:gs>
+            <a:gs pos="100000">
+              <a:schemeClr val="phClr">
+                <a:lumMod val="99000"/>
+                <a:satMod val="120000"/>
+                <a:shade val="78000"/>
+              </a:schemeClr>
+            </a:gs>
+          </a:gsLst>
+          <a:lin ang="5400000" scaled="0"/>
+        </a:gradFill>
+      </a:fillStyleLst>
+      <a:lnStyleLst>
+        <a:ln w="12700" cap="flat" cmpd="sng" algn="ctr">
+          <a:solidFill>
+            <a:schemeClr val="phClr"/>
+          </a:solidFill>
+          <a:prstDash val="solid"/>
+          <a:miter lim="800000"/>
+        </a:ln>
+        <a:ln w="19050" cap="flat" cmpd="sng" algn="ctr">
+          <a:solidFill>
+            <a:schemeClr val="phClr"/>
+          </a:solidFill>
+          <a:prstDash val="solid"/>
+          <a:miter lim="800000"/>
+        </a:ln>
+        <a:ln w="25400" cap="flat" cmpd="sng" algn="ctr">
+          <a:solidFill>
+            <a:schemeClr val="phClr"/>
+          </a:solidFill>
+          <a:prstDash val="solid"/>
+          <a:miter lim="800000"/>
+        </a:ln>
+      </a:lnStyleLst>
+      <a:effectStyleLst>
+        <a:effectStyle>
+          <a:effectLst/>
+        </a:effectStyle>
+        <a:effectStyle>
+          <a:effectLst/>
+        </a:effectStyle>
+        <a:effectStyle>
+          <a:effectLst>
+            <a:outerShdw blurRad="57150" dist="19050" dir="5400000" algn="ctr" rotWithShape="0">
+              <a:srgbClr val="000000">
+                <a:alpha val="63000"/>
+              </a:srgbClr>
+            </a:outerShdw>
+          </a:effectLst>
+        </a:effectStyle>
+      </a:effectStyleLst>
+      <a:bgFillStyleLst>
+        <a:solidFill>
+          <a:schemeClr val="phClr"/>
+        </a:solidFill>
+        <a:solidFill>
+          <a:schemeClr val="phClr">
+            <a:tint val="95000"/>
+            <a:satMod val="170000"/>
+          </a:schemeClr>
+        </a:solidFill>
+        <a:gradFill rotWithShape="1">
+          <a:gsLst>
+            <a:gs pos="0">
+              <a:schemeClr val="phClr">
+                <a:tint val="93000"/>
+                <a:satMod val="150000"/>
+                <a:shade val="98000"/>
+                <a:lumMod val="102000"/>
+              </a:schemeClr>
+            </a:gs>
+            <a:gs pos="50000">
+              <a:schemeClr val="phClr">
+                <a:tint val="98000"/>
+                <a:satMod val="130000"/>
+                <a:shade val="90000"/>
+                <a:lumMod val="103000"/>
+              </a:schemeClr>
+            </a:gs>
+            <a:gs pos="100000">
+              <a:schemeClr val="phClr">
+                <a:shade val="63000"/>
+                <a:satMod val="120000"/>
+              </a:schemeClr>
+            </a:gs>
+          </a:gsLst>
+          <a:lin ang="5400000" scaled="0"/>
+        </a:gradFill>
+      </a:bgFillStyleLst>
+    </a:fmtScheme>
+  </a:themeElements>
+  <a:objectDefaults>
+    <a:lnDef>
+      <a:spPr/>
+      <a:bodyPr/>
+      <a:lstStyle/>
+      <a:style>
+        <a:lnRef idx="2">
+          <a:schemeClr val="accent1"/>
+        </a:lnRef>
+        <a:fillRef idx="0">
+          <a:schemeClr val="accent1"/>
+        </a:fillRef>
+        <a:effectRef idx="1">
+          <a:schemeClr val="accent1"/>
+        </a:effectRef>
+        <a:fontRef idx="minor">
+          <a:schemeClr val="tx1"/>
+        </a:fontRef>
+      </a:style>
+    </a:lnDef>
+  </a:objectDefaults>
+  <a:extraClrSchemeLst/>
+  <a:extLst>
+    <a:ext uri="{05A4C25C-085E-4340-85A3-A5531E510DB2}">
+      <thm15:themeFamily xmlns:thm15="http://schemas.microsoft.com/office/thememl/2012/main" name="Office Theme" id="{2E142A2C-CD16-42D6-873A-C26D2A0506FA}" vid="{1BDDFF52-6CD6-40A5-AB3C-68EB2F1E4D0A}"/>
+    </a:ext>
+  </a:extLst>
+</a:theme>
 </file>
</xml_diff>